<commit_message>
docs(pptx): Expand Presentacion_Centinela_AI.pptx with 3 new dedicated executive/developer glossary slides (14 slides total)
</commit_message>
<xml_diff>
--- a/Presentacion_Centinela_AI.pptx
+++ b/Presentacion_Centinela_AI.pptx
@@ -16,6 +16,9 @@
     <p:sldId id="264" r:id="rId15"/>
     <p:sldId id="265" r:id="rId16"/>
     <p:sldId id="266" r:id="rId17"/>
+    <p:sldId id="267" r:id="rId18"/>
+    <p:sldId id="268" r:id="rId19"/>
+    <p:sldId id="269" r:id="rId20"/>
   </p:sldIdLst>
   <p:sldSz cx="12191695" cy="6858000" type="screen4x3"/>
   <p:notesSz cx="6858000" cy="9144000"/>
@@ -3315,7 +3318,7 @@
               </a:defRPr>
             </a:pPr>
             <a:r>
-              <a:t>9. Estrategia de Comercialización Futura</a:t>
+              <a:t>6. Correlación de Riesgo (CRS) y Motor IA</a:t>
             </a:r>
           </a:p>
           <a:p>
@@ -3327,7 +3330,7 @@
               </a:defRPr>
             </a:pPr>
             <a:r>
-              <a:t>¿Cómo monetizar Centinela-AI como Producto B2B?</a:t>
+              <a:t>Cálculo de criticidad y resiliencia multi-proveedor de LLM</a:t>
             </a:r>
           </a:p>
         </p:txBody>
@@ -3381,20 +3384,20 @@
               </a:defRPr>
             </a:pPr>
             <a:r>
-              <a:t>☁️ SaaS Enterprise (Cloud)</a:t>
+              <a:t>Centinela Risk Score (CRS)</a:t>
             </a:r>
           </a:p>
           <a:p>
             <a:br/>
             <a:pPr>
-              <a:defRPr sz="1400">
+              <a:defRPr sz="1300">
                 <a:solidFill>
                   <a:srgbClr val="F8FAFC"/>
                 </a:solidFill>
               </a:defRPr>
             </a:pPr>
             <a:r>
-              <a:t>Suscripción mensual/anual basada en la cantidad de activos monitoreados (repositorios, servidores, contenedores).</a:t>
+              <a:t>Puntuación 0-100 por hallazgo. Combina la severidad CVSS con probabilidad de explotación real (EPSS de FIRST.org en vivo), CISA KEV (ataques confirmados en el mundo) y la criticidad del activo.</a:t>
             </a:r>
           </a:p>
         </p:txBody>
@@ -3448,20 +3451,28 @@
               </a:defRPr>
             </a:pPr>
             <a:r>
-              <a:t>🏢 Enterprise On-Premise</a:t>
+              <a:t>Cadena Multi-Proveedor LLM</a:t>
             </a:r>
           </a:p>
           <a:p>
             <a:br/>
             <a:pPr>
-              <a:defRPr sz="1400">
+              <a:defRPr sz="1300">
                 <a:solidFill>
                   <a:srgbClr val="F8FAFC"/>
                 </a:solidFill>
               </a:defRPr>
             </a:pPr>
             <a:r>
-              <a:t>Licenciamiento anual para sectores regulados (Banca, Gobierno, Salud) con despliegue local o Air-Gapped.</a:t>
+              <a:t>Cadena de resiliencia con fallback automático en cada llamada:</a:t>
+            </a:r>
+            <a:br/>
+            <a:r>
+              <a:t>Groq → Google Gemini → NVIDIA NIM → OpenRouter → Motor Heurístico Determinístico.</a:t>
+            </a:r>
+            <a:br/>
+            <a:r>
+              <a:t>Garantiza disponibilidad constante si una API agota cuota.</a:t>
             </a:r>
           </a:p>
         </p:txBody>
@@ -3515,20 +3526,20 @@
               </a:defRPr>
             </a:pPr>
             <a:r>
-              <a:t>🤝 Partner MSSP Program</a:t>
+              <a:t>Validación Estricta de Parches</a:t>
             </a:r>
           </a:p>
           <a:p>
             <a:br/>
             <a:pPr>
-              <a:defRPr sz="1400">
+              <a:defRPr sz="1300">
                 <a:solidFill>
                   <a:srgbClr val="F8FAFC"/>
                 </a:solidFill>
               </a:defRPr>
             </a:pPr>
             <a:r>
-              <a:t>Modelo Multitenant para consultoras de ciberseguridad que ofrecen servicios SOC/DevSecOps gestionados.</a:t>
+              <a:t>La IA genera diffs unificados (`git apply`) o scripts Bash. Centinela valida que la respuesta no sea texto de relleno (`... script provisto`); si la calidad es baja, cae automáticamente al motor determinístico.</a:t>
             </a:r>
           </a:p>
         </p:txBody>
@@ -3598,6 +3609,1030 @@
       </p:sp>
       <p:sp>
         <p:nvSpPr>
+          <p:cNvPr id="3" name="TextBox 2"/>
+          <p:cNvSpPr txBox="1"/>
+          <p:nvPr/>
+        </p:nvSpPr>
+        <p:spPr>
+          <a:xfrm>
+            <a:off x="731520" y="365760"/>
+            <a:ext cx="10698480" cy="822960"/>
+          </a:xfrm>
+          <a:prstGeom prst="rect">
+            <a:avLst/>
+          </a:prstGeom>
+          <a:noFill/>
+        </p:spPr>
+        <p:txBody>
+          <a:bodyPr wrap="square">
+            <a:spAutoFit/>
+          </a:bodyPr>
+          <a:lstStyle/>
+          <a:p>
+            <a:pPr>
+              <a:defRPr sz="2600" b="1">
+                <a:solidFill>
+                  <a:srgbClr val="0EA5E9"/>
+                </a:solidFill>
+              </a:defRPr>
+            </a:pPr>
+            <a:r>
+              <a:t>7. Funcionamiento del SOAR 2.0 y Remediación</a:t>
+            </a:r>
+          </a:p>
+          <a:p>
+            <a:pPr>
+              <a:defRPr sz="1300">
+                <a:solidFill>
+                  <a:srgbClr val="94A3B8"/>
+                </a:solidFill>
+              </a:defRPr>
+            </a:pPr>
+            <a:r>
+              <a:t>Flujo de ejecución defensiva automatizada con Human-in-the-Loop</a:t>
+            </a:r>
+          </a:p>
+        </p:txBody>
+      </p:sp>
+      <p:sp>
+        <p:nvSpPr>
+          <p:cNvPr id="4" name="Rounded Rectangle 3"/>
+          <p:cNvSpPr/>
+          <p:nvPr/>
+        </p:nvSpPr>
+        <p:spPr>
+          <a:xfrm>
+            <a:off x="731520" y="1554480"/>
+            <a:ext cx="5212080" cy="2103120"/>
+          </a:xfrm>
+          <a:prstGeom prst="roundRect">
+            <a:avLst/>
+          </a:prstGeom>
+          <a:solidFill>
+            <a:srgbClr val="1E293B"/>
+          </a:solidFill>
+          <a:ln>
+            <a:solidFill>
+              <a:srgbClr val="334155"/>
+            </a:solidFill>
+          </a:ln>
+        </p:spPr>
+        <p:style>
+          <a:lnRef idx="1">
+            <a:schemeClr val="accent1"/>
+          </a:lnRef>
+          <a:fillRef idx="3">
+            <a:schemeClr val="accent1"/>
+          </a:fillRef>
+          <a:effectRef idx="2">
+            <a:schemeClr val="accent1"/>
+          </a:effectRef>
+          <a:fontRef idx="minor">
+            <a:schemeClr val="lt1"/>
+          </a:fontRef>
+        </p:style>
+        <p:txBody>
+          <a:bodyPr rtlCol="0" anchor="ctr" wrap="square"/>
+          <a:lstStyle/>
+          <a:p>
+            <a:pPr algn="ctr">
+              <a:defRPr sz="1600" b="1">
+                <a:solidFill>
+                  <a:srgbClr val="22C55E"/>
+                </a:solidFill>
+              </a:defRPr>
+            </a:pPr>
+            <a:r>
+              <a:t>1. Evaluación de Confianza</a:t>
+            </a:r>
+          </a:p>
+          <a:p>
+            <a:br/>
+            <a:pPr>
+              <a:defRPr sz="1300">
+                <a:solidFill>
+                  <a:srgbClr val="F8FAFC"/>
+                </a:solidFill>
+              </a:defRPr>
+            </a:pPr>
+            <a:r>
+              <a:t>Si la confianza del parche es ≥95% (Virtual Patching Nginx / Revocación Authentik), se ejecuta respuesta inmediata. Si es &lt;95%, requiere aprobación 1-click.</a:t>
+            </a:r>
+          </a:p>
+        </p:txBody>
+      </p:sp>
+      <p:sp>
+        <p:nvSpPr>
+          <p:cNvPr id="5" name="Rounded Rectangle 4"/>
+          <p:cNvSpPr/>
+          <p:nvPr/>
+        </p:nvSpPr>
+        <p:spPr>
+          <a:xfrm>
+            <a:off x="6126480" y="1554480"/>
+            <a:ext cx="5212080" cy="2103120"/>
+          </a:xfrm>
+          <a:prstGeom prst="roundRect">
+            <a:avLst/>
+          </a:prstGeom>
+          <a:solidFill>
+            <a:srgbClr val="1E293B"/>
+          </a:solidFill>
+          <a:ln>
+            <a:solidFill>
+              <a:srgbClr val="334155"/>
+            </a:solidFill>
+          </a:ln>
+        </p:spPr>
+        <p:style>
+          <a:lnRef idx="1">
+            <a:schemeClr val="accent1"/>
+          </a:lnRef>
+          <a:fillRef idx="3">
+            <a:schemeClr val="accent1"/>
+          </a:fillRef>
+          <a:effectRef idx="2">
+            <a:schemeClr val="accent1"/>
+          </a:effectRef>
+          <a:fontRef idx="minor">
+            <a:schemeClr val="lt1"/>
+          </a:fontRef>
+        </p:style>
+        <p:txBody>
+          <a:bodyPr rtlCol="0" anchor="ctr" wrap="square"/>
+          <a:lstStyle/>
+          <a:p>
+            <a:pPr algn="ctr">
+              <a:defRPr sz="1600" b="1">
+                <a:solidFill>
+                  <a:srgbClr val="22C55E"/>
+                </a:solidFill>
+              </a:defRPr>
+            </a:pPr>
+            <a:r>
+              <a:t>2. Remediación en Servidores</a:t>
+            </a:r>
+          </a:p>
+          <a:p>
+            <a:br/>
+            <a:pPr>
+              <a:defRPr sz="1300">
+                <a:solidFill>
+                  <a:srgbClr val="F8FAFC"/>
+                </a:solidFill>
+              </a:defRPr>
+            </a:pPr>
+            <a:r>
+              <a:t>Sentinel se autentica vía Vault (credenciales SSH/sudo dedicadas `NOPASSWD` acotadas) y ejecuta Playbooks de Ansible. Si el comando falla, el estado se marca `FAILED`.</a:t>
+            </a:r>
+          </a:p>
+        </p:txBody>
+      </p:sp>
+      <p:sp>
+        <p:nvSpPr>
+          <p:cNvPr id="6" name="Rounded Rectangle 5"/>
+          <p:cNvSpPr/>
+          <p:nvPr/>
+        </p:nvSpPr>
+        <p:spPr>
+          <a:xfrm>
+            <a:off x="731520" y="3840480"/>
+            <a:ext cx="5212080" cy="2103120"/>
+          </a:xfrm>
+          <a:prstGeom prst="roundRect">
+            <a:avLst/>
+          </a:prstGeom>
+          <a:solidFill>
+            <a:srgbClr val="1E293B"/>
+          </a:solidFill>
+          <a:ln>
+            <a:solidFill>
+              <a:srgbClr val="334155"/>
+            </a:solidFill>
+          </a:ln>
+        </p:spPr>
+        <p:style>
+          <a:lnRef idx="1">
+            <a:schemeClr val="accent1"/>
+          </a:lnRef>
+          <a:fillRef idx="3">
+            <a:schemeClr val="accent1"/>
+          </a:fillRef>
+          <a:effectRef idx="2">
+            <a:schemeClr val="accent1"/>
+          </a:effectRef>
+          <a:fontRef idx="minor">
+            <a:schemeClr val="lt1"/>
+          </a:fontRef>
+        </p:style>
+        <p:txBody>
+          <a:bodyPr rtlCol="0" anchor="ctr" wrap="square"/>
+          <a:lstStyle/>
+          <a:p>
+            <a:pPr algn="ctr">
+              <a:defRPr sz="1600" b="1">
+                <a:solidFill>
+                  <a:srgbClr val="22C55E"/>
+                </a:solidFill>
+              </a:defRPr>
+            </a:pPr>
+            <a:r>
+              <a:t>3. Remediación en GitLab</a:t>
+            </a:r>
+          </a:p>
+          <a:p>
+            <a:br/>
+            <a:pPr>
+              <a:defRPr sz="1300">
+                <a:solidFill>
+                  <a:srgbClr val="F8FAFC"/>
+                </a:solidFill>
+              </a:defRPr>
+            </a:pPr>
+            <a:r>
+              <a:t>Sentinel clona el repositorio, aplica el diff unificado en una rama `centinela-fix/*` y abre un Merge Request formal con detalles normativos. NUNCA hace push directo a main.</a:t>
+            </a:r>
+          </a:p>
+        </p:txBody>
+      </p:sp>
+      <p:sp>
+        <p:nvSpPr>
+          <p:cNvPr id="7" name="Rounded Rectangle 6"/>
+          <p:cNvSpPr/>
+          <p:nvPr/>
+        </p:nvSpPr>
+        <p:spPr>
+          <a:xfrm>
+            <a:off x="6126480" y="3840480"/>
+            <a:ext cx="5212080" cy="2103120"/>
+          </a:xfrm>
+          <a:prstGeom prst="roundRect">
+            <a:avLst/>
+          </a:prstGeom>
+          <a:solidFill>
+            <a:srgbClr val="1E293B"/>
+          </a:solidFill>
+          <a:ln>
+            <a:solidFill>
+              <a:srgbClr val="334155"/>
+            </a:solidFill>
+          </a:ln>
+        </p:spPr>
+        <p:style>
+          <a:lnRef idx="1">
+            <a:schemeClr val="accent1"/>
+          </a:lnRef>
+          <a:fillRef idx="3">
+            <a:schemeClr val="accent1"/>
+          </a:fillRef>
+          <a:effectRef idx="2">
+            <a:schemeClr val="accent1"/>
+          </a:effectRef>
+          <a:fontRef idx="minor">
+            <a:schemeClr val="lt1"/>
+          </a:fontRef>
+        </p:style>
+        <p:txBody>
+          <a:bodyPr rtlCol="0" anchor="ctr" wrap="square"/>
+          <a:lstStyle/>
+          <a:p>
+            <a:pPr algn="ctr">
+              <a:defRPr sz="1600" b="1">
+                <a:solidFill>
+                  <a:srgbClr val="22C55E"/>
+                </a:solidFill>
+              </a:defRPr>
+            </a:pPr>
+            <a:r>
+              <a:t>4. Trazabilidad Inmutable</a:t>
+            </a:r>
+          </a:p>
+          <a:p>
+            <a:br/>
+            <a:pPr>
+              <a:defRPr sz="1300">
+                <a:solidFill>
+                  <a:srgbClr val="F8FAFC"/>
+                </a:solidFill>
+              </a:defRPr>
+            </a:pPr>
+            <a:r>
+              <a:t>Todo evento de remediación se registra en PostgreSQL y auditoría STRIDE, garantizando no-repudio y visibilidad completa para los auditores de seguridad.</a:t>
+            </a:r>
+          </a:p>
+        </p:txBody>
+      </p:sp>
+    </p:spTree>
+  </p:cSld>
+  <p:clrMapOvr>
+    <a:masterClrMapping/>
+  </p:clrMapOvr>
+</p:sld>
+</file>
+
+<file path=ppt/slides/slide12.xml><?xml version="1.0" encoding="utf-8"?>
+<p:sld xmlns:a="http://schemas.openxmlformats.org/drawingml/2006/main" xmlns:p="http://schemas.openxmlformats.org/presentationml/2006/main" xmlns:r="http://schemas.openxmlformats.org/officeDocument/2006/relationships">
+  <p:cSld>
+    <p:spTree>
+      <p:nvGrpSpPr>
+        <p:cNvPr id="1" name=""/>
+        <p:cNvGrpSpPr/>
+        <p:nvPr/>
+      </p:nvGrpSpPr>
+      <p:grpSpPr/>
+      <p:sp>
+        <p:nvSpPr>
+          <p:cNvPr id="2" name="Rectangle 1"/>
+          <p:cNvSpPr/>
+          <p:nvPr/>
+        </p:nvSpPr>
+        <p:spPr>
+          <a:xfrm>
+            <a:off x="0" y="0"/>
+            <a:ext cx="12191695" cy="6858000"/>
+          </a:xfrm>
+          <a:prstGeom prst="rect">
+            <a:avLst/>
+          </a:prstGeom>
+          <a:solidFill>
+            <a:srgbClr val="0F172A"/>
+          </a:solidFill>
+          <a:ln>
+            <a:solidFill>
+              <a:srgbClr val="0F172A"/>
+            </a:solidFill>
+          </a:ln>
+        </p:spPr>
+        <p:style>
+          <a:lnRef idx="1">
+            <a:schemeClr val="accent1"/>
+          </a:lnRef>
+          <a:fillRef idx="3">
+            <a:schemeClr val="accent1"/>
+          </a:fillRef>
+          <a:effectRef idx="2">
+            <a:schemeClr val="accent1"/>
+          </a:effectRef>
+          <a:fontRef idx="minor">
+            <a:schemeClr val="lt1"/>
+          </a:fontRef>
+        </p:style>
+        <p:txBody>
+          <a:bodyPr rtlCol="0" anchor="ctr"/>
+          <a:lstStyle/>
+          <a:p>
+            <a:pPr algn="ctr"/>
+          </a:p>
+        </p:txBody>
+      </p:sp>
+      <p:sp>
+        <p:nvSpPr>
+          <p:cNvPr id="3" name="TextBox 2"/>
+          <p:cNvSpPr txBox="1"/>
+          <p:nvPr/>
+        </p:nvSpPr>
+        <p:spPr>
+          <a:xfrm>
+            <a:off x="731520" y="365760"/>
+            <a:ext cx="10698480" cy="822960"/>
+          </a:xfrm>
+          <a:prstGeom prst="rect">
+            <a:avLst/>
+          </a:prstGeom>
+          <a:noFill/>
+        </p:spPr>
+        <p:txBody>
+          <a:bodyPr wrap="square">
+            <a:spAutoFit/>
+          </a:bodyPr>
+          <a:lstStyle/>
+          <a:p>
+            <a:pPr>
+              <a:defRPr sz="2600" b="1">
+                <a:solidFill>
+                  <a:srgbClr val="0EA5E9"/>
+                </a:solidFill>
+              </a:defRPr>
+            </a:pPr>
+            <a:r>
+              <a:t>8. Beneficios Organizacionales</a:t>
+            </a:r>
+          </a:p>
+          <a:p>
+            <a:pPr>
+              <a:defRPr sz="1300">
+                <a:solidFill>
+                  <a:srgbClr val="94A3B8"/>
+                </a:solidFill>
+              </a:defRPr>
+            </a:pPr>
+            <a:r>
+              <a:t>¿Qué aporta su uso a cada rol en la empresa?</a:t>
+            </a:r>
+          </a:p>
+        </p:txBody>
+      </p:sp>
+      <p:sp>
+        <p:nvSpPr>
+          <p:cNvPr id="4" name="Rounded Rectangle 3"/>
+          <p:cNvSpPr/>
+          <p:nvPr/>
+        </p:nvSpPr>
+        <p:spPr>
+          <a:xfrm>
+            <a:off x="731520" y="1645920"/>
+            <a:ext cx="3383280" cy="4389120"/>
+          </a:xfrm>
+          <a:prstGeom prst="roundRect">
+            <a:avLst/>
+          </a:prstGeom>
+          <a:solidFill>
+            <a:srgbClr val="1E293B"/>
+          </a:solidFill>
+          <a:ln>
+            <a:solidFill>
+              <a:srgbClr val="334155"/>
+            </a:solidFill>
+          </a:ln>
+        </p:spPr>
+        <p:style>
+          <a:lnRef idx="1">
+            <a:schemeClr val="accent1"/>
+          </a:lnRef>
+          <a:fillRef idx="3">
+            <a:schemeClr val="accent1"/>
+          </a:fillRef>
+          <a:effectRef idx="2">
+            <a:schemeClr val="accent1"/>
+          </a:effectRef>
+          <a:fontRef idx="minor">
+            <a:schemeClr val="lt1"/>
+          </a:fontRef>
+        </p:style>
+        <p:txBody>
+          <a:bodyPr rtlCol="0" anchor="ctr" wrap="square"/>
+          <a:lstStyle/>
+          <a:p>
+            <a:pPr algn="ctr">
+              <a:defRPr sz="1600" b="1">
+                <a:solidFill>
+                  <a:srgbClr val="0EA5E9"/>
+                </a:solidFill>
+              </a:defRPr>
+            </a:pPr>
+            <a:r>
+              <a:t>👔 Para la Dirección / C-Level</a:t>
+            </a:r>
+          </a:p>
+          <a:p>
+            <a:br/>
+            <a:pPr>
+              <a:defRPr sz="1300">
+                <a:solidFill>
+                  <a:srgbClr val="F8FAFC"/>
+                </a:solidFill>
+              </a:defRPr>
+            </a:pPr>
+            <a:r>
+              <a:t>• Reducción radical del riesgo de brechas.</a:t>
+            </a:r>
+            <a:br/>
+            <a:r>
+              <a:t>• Ahorro directo por consolidación de herramientas.</a:t>
+            </a:r>
+            <a:br/>
+            <a:r>
+              <a:t>• Reportes ejecutivos de cumplimiento (ISO/NIST/PCI).</a:t>
+            </a:r>
+          </a:p>
+        </p:txBody>
+      </p:sp>
+      <p:sp>
+        <p:nvSpPr>
+          <p:cNvPr id="5" name="Rounded Rectangle 4"/>
+          <p:cNvSpPr/>
+          <p:nvPr/>
+        </p:nvSpPr>
+        <p:spPr>
+          <a:xfrm>
+            <a:off x="4297680" y="1645920"/>
+            <a:ext cx="3383280" cy="4389120"/>
+          </a:xfrm>
+          <a:prstGeom prst="roundRect">
+            <a:avLst/>
+          </a:prstGeom>
+          <a:solidFill>
+            <a:srgbClr val="1E293B"/>
+          </a:solidFill>
+          <a:ln>
+            <a:solidFill>
+              <a:srgbClr val="334155"/>
+            </a:solidFill>
+          </a:ln>
+        </p:spPr>
+        <p:style>
+          <a:lnRef idx="1">
+            <a:schemeClr val="accent1"/>
+          </a:lnRef>
+          <a:fillRef idx="3">
+            <a:schemeClr val="accent1"/>
+          </a:fillRef>
+          <a:effectRef idx="2">
+            <a:schemeClr val="accent1"/>
+          </a:effectRef>
+          <a:fontRef idx="minor">
+            <a:schemeClr val="lt1"/>
+          </a:fontRef>
+        </p:style>
+        <p:txBody>
+          <a:bodyPr rtlCol="0" anchor="ctr" wrap="square"/>
+          <a:lstStyle/>
+          <a:p>
+            <a:pPr algn="ctr">
+              <a:defRPr sz="1600" b="1">
+                <a:solidFill>
+                  <a:srgbClr val="6366F1"/>
+                </a:solidFill>
+              </a:defRPr>
+            </a:pPr>
+            <a:r>
+              <a:t>🛡️ Para Líder de Equipo / SOC</a:t>
+            </a:r>
+          </a:p>
+          <a:p>
+            <a:br/>
+            <a:pPr>
+              <a:defRPr sz="1300">
+                <a:solidFill>
+                  <a:srgbClr val="F8FAFC"/>
+                </a:solidFill>
+              </a:defRPr>
+            </a:pPr>
+            <a:r>
+              <a:t>• Tablero unificado Single-Pane-of-Glass.</a:t>
+            </a:r>
+            <a:br/>
+            <a:r>
+              <a:t>• Priorización basada en riesgo real (EPSS/KEV).</a:t>
+            </a:r>
+            <a:br/>
+            <a:r>
+              <a:t>• Quality Gates para pipelines CI/CD.</a:t>
+            </a:r>
+          </a:p>
+        </p:txBody>
+      </p:sp>
+      <p:sp>
+        <p:nvSpPr>
+          <p:cNvPr id="6" name="Rounded Rectangle 5"/>
+          <p:cNvSpPr/>
+          <p:nvPr/>
+        </p:nvSpPr>
+        <p:spPr>
+          <a:xfrm>
+            <a:off x="7863840" y="1645920"/>
+            <a:ext cx="3383280" cy="4389120"/>
+          </a:xfrm>
+          <a:prstGeom prst="roundRect">
+            <a:avLst/>
+          </a:prstGeom>
+          <a:solidFill>
+            <a:srgbClr val="1E293B"/>
+          </a:solidFill>
+          <a:ln>
+            <a:solidFill>
+              <a:srgbClr val="334155"/>
+            </a:solidFill>
+          </a:ln>
+        </p:spPr>
+        <p:style>
+          <a:lnRef idx="1">
+            <a:schemeClr val="accent1"/>
+          </a:lnRef>
+          <a:fillRef idx="3">
+            <a:schemeClr val="accent1"/>
+          </a:fillRef>
+          <a:effectRef idx="2">
+            <a:schemeClr val="accent1"/>
+          </a:effectRef>
+          <a:fontRef idx="minor">
+            <a:schemeClr val="lt1"/>
+          </a:fontRef>
+        </p:style>
+        <p:txBody>
+          <a:bodyPr rtlCol="0" anchor="ctr" wrap="square"/>
+          <a:lstStyle/>
+          <a:p>
+            <a:pPr algn="ctr">
+              <a:defRPr sz="1600" b="1">
+                <a:solidFill>
+                  <a:srgbClr val="0EA5E9"/>
+                </a:solidFill>
+              </a:defRPr>
+            </a:pPr>
+            <a:r>
+              <a:t>💻 Para el Equipo de Desarrollo</a:t>
+            </a:r>
+          </a:p>
+          <a:p>
+            <a:br/>
+            <a:pPr>
+              <a:defRPr sz="1300">
+                <a:solidFill>
+                  <a:srgbClr val="F8FAFC"/>
+                </a:solidFill>
+              </a:defRPr>
+            </a:pPr>
+            <a:r>
+              <a:t>• Fricción cero: Parches mediante MRs formales.</a:t>
+            </a:r>
+            <a:br/>
+            <a:r>
+              <a:t>• Explicaciones didácticas en cada MR.</a:t>
+            </a:r>
+            <a:br/>
+            <a:r>
+              <a:t>• Detección temprana en el ciclo DevSecOps.</a:t>
+            </a:r>
+          </a:p>
+        </p:txBody>
+      </p:sp>
+    </p:spTree>
+  </p:cSld>
+  <p:clrMapOvr>
+    <a:masterClrMapping/>
+  </p:clrMapOvr>
+</p:sld>
+</file>
+
+<file path=ppt/slides/slide13.xml><?xml version="1.0" encoding="utf-8"?>
+<p:sld xmlns:a="http://schemas.openxmlformats.org/drawingml/2006/main" xmlns:p="http://schemas.openxmlformats.org/presentationml/2006/main" xmlns:r="http://schemas.openxmlformats.org/officeDocument/2006/relationships">
+  <p:cSld>
+    <p:spTree>
+      <p:nvGrpSpPr>
+        <p:cNvPr id="1" name=""/>
+        <p:cNvGrpSpPr/>
+        <p:nvPr/>
+      </p:nvGrpSpPr>
+      <p:grpSpPr/>
+      <p:sp>
+        <p:nvSpPr>
+          <p:cNvPr id="2" name="Rectangle 1"/>
+          <p:cNvSpPr/>
+          <p:nvPr/>
+        </p:nvSpPr>
+        <p:spPr>
+          <a:xfrm>
+            <a:off x="0" y="0"/>
+            <a:ext cx="12191695" cy="6858000"/>
+          </a:xfrm>
+          <a:prstGeom prst="rect">
+            <a:avLst/>
+          </a:prstGeom>
+          <a:solidFill>
+            <a:srgbClr val="0F172A"/>
+          </a:solidFill>
+          <a:ln>
+            <a:solidFill>
+              <a:srgbClr val="0F172A"/>
+            </a:solidFill>
+          </a:ln>
+        </p:spPr>
+        <p:style>
+          <a:lnRef idx="1">
+            <a:schemeClr val="accent1"/>
+          </a:lnRef>
+          <a:fillRef idx="3">
+            <a:schemeClr val="accent1"/>
+          </a:fillRef>
+          <a:effectRef idx="2">
+            <a:schemeClr val="accent1"/>
+          </a:effectRef>
+          <a:fontRef idx="minor">
+            <a:schemeClr val="lt1"/>
+          </a:fontRef>
+        </p:style>
+        <p:txBody>
+          <a:bodyPr rtlCol="0" anchor="ctr"/>
+          <a:lstStyle/>
+          <a:p>
+            <a:pPr algn="ctr"/>
+          </a:p>
+        </p:txBody>
+      </p:sp>
+      <p:sp>
+        <p:nvSpPr>
+          <p:cNvPr id="3" name="TextBox 2"/>
+          <p:cNvSpPr txBox="1"/>
+          <p:nvPr/>
+        </p:nvSpPr>
+        <p:spPr>
+          <a:xfrm>
+            <a:off x="731520" y="365760"/>
+            <a:ext cx="10698480" cy="822960"/>
+          </a:xfrm>
+          <a:prstGeom prst="rect">
+            <a:avLst/>
+          </a:prstGeom>
+          <a:noFill/>
+        </p:spPr>
+        <p:txBody>
+          <a:bodyPr wrap="square">
+            <a:spAutoFit/>
+          </a:bodyPr>
+          <a:lstStyle/>
+          <a:p>
+            <a:pPr>
+              <a:defRPr sz="2600" b="1">
+                <a:solidFill>
+                  <a:srgbClr val="0EA5E9"/>
+                </a:solidFill>
+              </a:defRPr>
+            </a:pPr>
+            <a:r>
+              <a:t>9. Estrategia de Comercialización Futura</a:t>
+            </a:r>
+          </a:p>
+          <a:p>
+            <a:pPr>
+              <a:defRPr sz="1300">
+                <a:solidFill>
+                  <a:srgbClr val="94A3B8"/>
+                </a:solidFill>
+              </a:defRPr>
+            </a:pPr>
+            <a:r>
+              <a:t>¿Cómo monetizar Centinela-AI como Producto B2B?</a:t>
+            </a:r>
+          </a:p>
+        </p:txBody>
+      </p:sp>
+      <p:sp>
+        <p:nvSpPr>
+          <p:cNvPr id="4" name="Rounded Rectangle 3"/>
+          <p:cNvSpPr/>
+          <p:nvPr/>
+        </p:nvSpPr>
+        <p:spPr>
+          <a:xfrm>
+            <a:off x="731520" y="1645920"/>
+            <a:ext cx="3383280" cy="4389120"/>
+          </a:xfrm>
+          <a:prstGeom prst="roundRect">
+            <a:avLst/>
+          </a:prstGeom>
+          <a:solidFill>
+            <a:srgbClr val="1E293B"/>
+          </a:solidFill>
+          <a:ln>
+            <a:solidFill>
+              <a:srgbClr val="334155"/>
+            </a:solidFill>
+          </a:ln>
+        </p:spPr>
+        <p:style>
+          <a:lnRef idx="1">
+            <a:schemeClr val="accent1"/>
+          </a:lnRef>
+          <a:fillRef idx="3">
+            <a:schemeClr val="accent1"/>
+          </a:fillRef>
+          <a:effectRef idx="2">
+            <a:schemeClr val="accent1"/>
+          </a:effectRef>
+          <a:fontRef idx="minor">
+            <a:schemeClr val="lt1"/>
+          </a:fontRef>
+        </p:style>
+        <p:txBody>
+          <a:bodyPr rtlCol="0" anchor="ctr" wrap="square"/>
+          <a:lstStyle/>
+          <a:p>
+            <a:pPr algn="ctr">
+              <a:defRPr sz="1700" b="1">
+                <a:solidFill>
+                  <a:srgbClr val="0EA5E9"/>
+                </a:solidFill>
+              </a:defRPr>
+            </a:pPr>
+            <a:r>
+              <a:t>☁️ SaaS Enterprise (Cloud)</a:t>
+            </a:r>
+          </a:p>
+          <a:p>
+            <a:br/>
+            <a:pPr>
+              <a:defRPr sz="1400">
+                <a:solidFill>
+                  <a:srgbClr val="F8FAFC"/>
+                </a:solidFill>
+              </a:defRPr>
+            </a:pPr>
+            <a:r>
+              <a:t>Suscripción mensual/anual basada en la cantidad de activos monitoreados (repositorios, servidores, contenedores).</a:t>
+            </a:r>
+          </a:p>
+        </p:txBody>
+      </p:sp>
+      <p:sp>
+        <p:nvSpPr>
+          <p:cNvPr id="5" name="Rounded Rectangle 4"/>
+          <p:cNvSpPr/>
+          <p:nvPr/>
+        </p:nvSpPr>
+        <p:spPr>
+          <a:xfrm>
+            <a:off x="4297680" y="1645920"/>
+            <a:ext cx="3383280" cy="4389120"/>
+          </a:xfrm>
+          <a:prstGeom prst="roundRect">
+            <a:avLst/>
+          </a:prstGeom>
+          <a:solidFill>
+            <a:srgbClr val="1E293B"/>
+          </a:solidFill>
+          <a:ln>
+            <a:solidFill>
+              <a:srgbClr val="334155"/>
+            </a:solidFill>
+          </a:ln>
+        </p:spPr>
+        <p:style>
+          <a:lnRef idx="1">
+            <a:schemeClr val="accent1"/>
+          </a:lnRef>
+          <a:fillRef idx="3">
+            <a:schemeClr val="accent1"/>
+          </a:fillRef>
+          <a:effectRef idx="2">
+            <a:schemeClr val="accent1"/>
+          </a:effectRef>
+          <a:fontRef idx="minor">
+            <a:schemeClr val="lt1"/>
+          </a:fontRef>
+        </p:style>
+        <p:txBody>
+          <a:bodyPr rtlCol="0" anchor="ctr" wrap="square"/>
+          <a:lstStyle/>
+          <a:p>
+            <a:pPr algn="ctr">
+              <a:defRPr sz="1700" b="1">
+                <a:solidFill>
+                  <a:srgbClr val="0EA5E9"/>
+                </a:solidFill>
+              </a:defRPr>
+            </a:pPr>
+            <a:r>
+              <a:t>🏢 Enterprise On-Premise</a:t>
+            </a:r>
+          </a:p>
+          <a:p>
+            <a:br/>
+            <a:pPr>
+              <a:defRPr sz="1400">
+                <a:solidFill>
+                  <a:srgbClr val="F8FAFC"/>
+                </a:solidFill>
+              </a:defRPr>
+            </a:pPr>
+            <a:r>
+              <a:t>Licenciamiento anual para sectores regulados (Banca, Gobierno, Salud) con despliegue local o Air-Gapped.</a:t>
+            </a:r>
+          </a:p>
+        </p:txBody>
+      </p:sp>
+      <p:sp>
+        <p:nvSpPr>
+          <p:cNvPr id="6" name="Rounded Rectangle 5"/>
+          <p:cNvSpPr/>
+          <p:nvPr/>
+        </p:nvSpPr>
+        <p:spPr>
+          <a:xfrm>
+            <a:off x="7863840" y="1645920"/>
+            <a:ext cx="3383280" cy="4389120"/>
+          </a:xfrm>
+          <a:prstGeom prst="roundRect">
+            <a:avLst/>
+          </a:prstGeom>
+          <a:solidFill>
+            <a:srgbClr val="1E293B"/>
+          </a:solidFill>
+          <a:ln>
+            <a:solidFill>
+              <a:srgbClr val="334155"/>
+            </a:solidFill>
+          </a:ln>
+        </p:spPr>
+        <p:style>
+          <a:lnRef idx="1">
+            <a:schemeClr val="accent1"/>
+          </a:lnRef>
+          <a:fillRef idx="3">
+            <a:schemeClr val="accent1"/>
+          </a:fillRef>
+          <a:effectRef idx="2">
+            <a:schemeClr val="accent1"/>
+          </a:effectRef>
+          <a:fontRef idx="minor">
+            <a:schemeClr val="lt1"/>
+          </a:fontRef>
+        </p:style>
+        <p:txBody>
+          <a:bodyPr rtlCol="0" anchor="ctr" wrap="square"/>
+          <a:lstStyle/>
+          <a:p>
+            <a:pPr algn="ctr">
+              <a:defRPr sz="1700" b="1">
+                <a:solidFill>
+                  <a:srgbClr val="0EA5E9"/>
+                </a:solidFill>
+              </a:defRPr>
+            </a:pPr>
+            <a:r>
+              <a:t>🤝 Partner MSSP Program</a:t>
+            </a:r>
+          </a:p>
+          <a:p>
+            <a:br/>
+            <a:pPr>
+              <a:defRPr sz="1400">
+                <a:solidFill>
+                  <a:srgbClr val="F8FAFC"/>
+                </a:solidFill>
+              </a:defRPr>
+            </a:pPr>
+            <a:r>
+              <a:t>Modelo Multitenant para consultoras de ciberseguridad que ofrecen servicios SOC/DevSecOps gestionados.</a:t>
+            </a:r>
+          </a:p>
+        </p:txBody>
+      </p:sp>
+    </p:spTree>
+  </p:cSld>
+  <p:clrMapOvr>
+    <a:masterClrMapping/>
+  </p:clrMapOvr>
+</p:sld>
+</file>
+
+<file path=ppt/slides/slide14.xml><?xml version="1.0" encoding="utf-8"?>
+<p:sld xmlns:a="http://schemas.openxmlformats.org/drawingml/2006/main" xmlns:p="http://schemas.openxmlformats.org/presentationml/2006/main" xmlns:r="http://schemas.openxmlformats.org/officeDocument/2006/relationships">
+  <p:cSld>
+    <p:spTree>
+      <p:nvGrpSpPr>
+        <p:cNvPr id="1" name=""/>
+        <p:cNvGrpSpPr/>
+        <p:nvPr/>
+      </p:nvGrpSpPr>
+      <p:grpSpPr/>
+      <p:sp>
+        <p:nvSpPr>
+          <p:cNvPr id="2" name="Rectangle 1"/>
+          <p:cNvSpPr/>
+          <p:nvPr/>
+        </p:nvSpPr>
+        <p:spPr>
+          <a:xfrm>
+            <a:off x="0" y="0"/>
+            <a:ext cx="12191695" cy="6858000"/>
+          </a:xfrm>
+          <a:prstGeom prst="rect">
+            <a:avLst/>
+          </a:prstGeom>
+          <a:solidFill>
+            <a:srgbClr val="0F172A"/>
+          </a:solidFill>
+          <a:ln>
+            <a:solidFill>
+              <a:srgbClr val="0F172A"/>
+            </a:solidFill>
+          </a:ln>
+        </p:spPr>
+        <p:style>
+          <a:lnRef idx="1">
+            <a:schemeClr val="accent1"/>
+          </a:lnRef>
+          <a:fillRef idx="3">
+            <a:schemeClr val="accent1"/>
+          </a:fillRef>
+          <a:effectRef idx="2">
+            <a:schemeClr val="accent1"/>
+          </a:effectRef>
+          <a:fontRef idx="minor">
+            <a:schemeClr val="lt1"/>
+          </a:fontRef>
+        </p:style>
+        <p:txBody>
+          <a:bodyPr rtlCol="0" anchor="ctr"/>
+          <a:lstStyle/>
+          <a:p>
+            <a:pPr algn="ctr"/>
+          </a:p>
+        </p:txBody>
+      </p:sp>
+      <p:sp>
+        <p:nvSpPr>
           <p:cNvPr id="3" name="Rounded Rectangle 2"/>
           <p:cNvSpPr/>
           <p:nvPr/>
@@ -4408,7 +5443,7 @@
               </a:defRPr>
             </a:pPr>
             <a:r>
-              <a:t>3. Cobertura de Seguridad (6 Pilares)</a:t>
+              <a:t>3. Glosario: Negocio, Gobierno y Estándares</a:t>
             </a:r>
           </a:p>
           <a:p>
@@ -4420,7 +5455,7 @@
               </a:defRPr>
             </a:pPr>
             <a:r>
-              <a:t>¿Qué audita el sistema?</a:t>
+              <a:t>Definición clara para Directivos y Desarrolladores</a:t>
             </a:r>
           </a:p>
         </p:txBody>
@@ -4433,8 +5468,8 @@
         </p:nvSpPr>
         <p:spPr>
           <a:xfrm>
-            <a:off x="731520" y="1645920"/>
-            <a:ext cx="3383280" cy="2011680"/>
+            <a:off x="731520" y="1554480"/>
+            <a:ext cx="5212080" cy="2103120"/>
           </a:xfrm>
           <a:prstGeom prst="roundRect">
             <a:avLst/>
@@ -4467,27 +5502,31 @@
           <a:lstStyle/>
           <a:p>
             <a:pPr algn="ctr">
-              <a:defRPr sz="1600" b="1">
-                <a:solidFill>
-                  <a:srgbClr val="6366F1"/>
-                </a:solidFill>
-              </a:defRPr>
-            </a:pPr>
-            <a:r>
-              <a:t>1. SAST &amp; Clean Code</a:t>
+              <a:defRPr sz="1500" b="1">
+                <a:solidFill>
+                  <a:srgbClr val="0EA5E9"/>
+                </a:solidFill>
+              </a:defRPr>
+            </a:pPr>
+            <a:r>
+              <a:t>CMMI v3.0 Benchmark (2024-2026)</a:t>
             </a:r>
           </a:p>
           <a:p>
             <a:br/>
             <a:pPr>
-              <a:defRPr sz="1300">
+              <a:defRPr sz="1200">
                 <a:solidFill>
                   <a:srgbClr val="F8FAFC"/>
                 </a:solidFill>
               </a:defRPr>
             </a:pPr>
             <a:r>
-              <a:t>Motor AST nativo + Semgrep (SQLi, CMD Injection, SSRF, Secretos, ISO 25010).</a:t>
+              <a:t>• Ejecutivos: Mide la madurez de los procesos de desarrollo de software (Nivel 3 a 5).</a:t>
+            </a:r>
+            <a:br/>
+            <a:r>
+              <a:t>• Desarrolladores: Audita Análisis de Causa Raíz (CAR), Control de Proveedores (SAM) y Calidad de Proceso (PQA).</a:t>
             </a:r>
           </a:p>
         </p:txBody>
@@ -4500,8 +5539,8 @@
         </p:nvSpPr>
         <p:spPr>
           <a:xfrm>
-            <a:off x="4297680" y="1645920"/>
-            <a:ext cx="3383280" cy="2011680"/>
+            <a:off x="6126480" y="1554480"/>
+            <a:ext cx="5212080" cy="2103120"/>
           </a:xfrm>
           <a:prstGeom prst="roundRect">
             <a:avLst/>
@@ -4534,27 +5573,31 @@
           <a:lstStyle/>
           <a:p>
             <a:pPr algn="ctr">
-              <a:defRPr sz="1600" b="1">
-                <a:solidFill>
-                  <a:srgbClr val="6366F1"/>
-                </a:solidFill>
-              </a:defRPr>
-            </a:pPr>
-            <a:r>
-              <a:t>2. SCA &amp; Dependencias</a:t>
+              <a:defRPr sz="1500" b="1">
+                <a:solidFill>
+                  <a:srgbClr val="0EA5E9"/>
+                </a:solidFill>
+              </a:defRPr>
+            </a:pPr>
+            <a:r>
+              <a:t>ISO/IEC 27001:2022 SGSI</a:t>
             </a:r>
           </a:p>
           <a:p>
             <a:br/>
             <a:pPr>
-              <a:defRPr sz="1300">
+              <a:defRPr sz="1200">
                 <a:solidFill>
                   <a:srgbClr val="F8FAFC"/>
                 </a:solidFill>
               </a:defRPr>
             </a:pPr>
             <a:r>
-              <a:t>Escaneo de paquetes npm/pip en vivo contra OSV.dev con análisis de alcanzabilidad.</a:t>
+              <a:t>• Ejecutivos: Norma internacional de Gestión de Seguridad de la Información.</a:t>
+            </a:r>
+            <a:br/>
+            <a:r>
+              <a:t>• Desarrolladores: Control A.8.8 (Gestión de Vulnerabilidades) y Control A.8.16 (Monitoreo de Eventos).</a:t>
             </a:r>
           </a:p>
         </p:txBody>
@@ -4567,8 +5610,8 @@
         </p:nvSpPr>
         <p:spPr>
           <a:xfrm>
-            <a:off x="7863840" y="1645920"/>
-            <a:ext cx="3383280" cy="2011680"/>
+            <a:off x="731520" y="3840480"/>
+            <a:ext cx="5212080" cy="2103120"/>
           </a:xfrm>
           <a:prstGeom prst="roundRect">
             <a:avLst/>
@@ -4601,27 +5644,31 @@
           <a:lstStyle/>
           <a:p>
             <a:pPr algn="ctr">
-              <a:defRPr sz="1600" b="1">
-                <a:solidFill>
-                  <a:srgbClr val="6366F1"/>
-                </a:solidFill>
-              </a:defRPr>
-            </a:pPr>
-            <a:r>
-              <a:t>3. Hardening &amp; IaC</a:t>
+              <a:defRPr sz="1500" b="1">
+                <a:solidFill>
+                  <a:srgbClr val="0EA5E9"/>
+                </a:solidFill>
+              </a:defRPr>
+            </a:pPr>
+            <a:r>
+              <a:t>ISO/IEC 25010 / 25001 (SQuaRE)</a:t>
             </a:r>
           </a:p>
           <a:p>
             <a:br/>
             <a:pPr>
-              <a:defRPr sz="1300">
+              <a:defRPr sz="1200">
                 <a:solidFill>
                   <a:srgbClr val="F8FAFC"/>
                 </a:solidFill>
               </a:defRPr>
             </a:pPr>
             <a:r>
-              <a:t>Checkov (Terraform/K8s), Dockerfiles no-root y CIS Benchmarks Linux SSH.</a:t>
+              <a:t>• Ejecutivos: Estándar de Calidad y Mantenibilidad del Software.</a:t>
+            </a:r>
+            <a:br/>
+            <a:r>
+              <a:t>• Desarrolladores: Evalúa Complejidad Cognitiva &lt; 15, ausencia de sleep y cero deuda técnica.</a:t>
             </a:r>
           </a:p>
         </p:txBody>
@@ -4634,8 +5681,8 @@
         </p:nvSpPr>
         <p:spPr>
           <a:xfrm>
-            <a:off x="731520" y="3931920"/>
-            <a:ext cx="3383280" cy="2011680"/>
+            <a:off x="6126480" y="3840480"/>
+            <a:ext cx="5212080" cy="2103120"/>
           </a:xfrm>
           <a:prstGeom prst="roundRect">
             <a:avLst/>
@@ -4668,161 +5715,31 @@
           <a:lstStyle/>
           <a:p>
             <a:pPr algn="ctr">
-              <a:defRPr sz="1600" b="1">
-                <a:solidFill>
-                  <a:srgbClr val="6366F1"/>
-                </a:solidFill>
-              </a:defRPr>
-            </a:pPr>
-            <a:r>
-              <a:t>4. Gobernanza de IA</a:t>
+              <a:defRPr sz="1500" b="1">
+                <a:solidFill>
+                  <a:srgbClr val="0EA5E9"/>
+                </a:solidFill>
+              </a:defRPr>
+            </a:pPr>
+            <a:r>
+              <a:t>Filosofía Shift Left</a:t>
             </a:r>
           </a:p>
           <a:p>
             <a:br/>
             <a:pPr>
-              <a:defRPr sz="1300">
+              <a:defRPr sz="1200">
                 <a:solidFill>
                   <a:srgbClr val="F8FAFC"/>
                 </a:solidFill>
               </a:defRPr>
             </a:pPr>
             <a:r>
-              <a:t>OWASP LLM Top 10 via Medusa-Security (Prompt Injection, fuga de PII).</a:t>
-            </a:r>
-          </a:p>
-        </p:txBody>
-      </p:sp>
-      <p:sp>
-        <p:nvSpPr>
-          <p:cNvPr id="8" name="Rounded Rectangle 7"/>
-          <p:cNvSpPr/>
-          <p:nvPr/>
-        </p:nvSpPr>
-        <p:spPr>
-          <a:xfrm>
-            <a:off x="4297680" y="3931920"/>
-            <a:ext cx="3383280" cy="2011680"/>
-          </a:xfrm>
-          <a:prstGeom prst="roundRect">
-            <a:avLst/>
-          </a:prstGeom>
-          <a:solidFill>
-            <a:srgbClr val="1E293B"/>
-          </a:solidFill>
-          <a:ln>
-            <a:solidFill>
-              <a:srgbClr val="334155"/>
-            </a:solidFill>
-          </a:ln>
-        </p:spPr>
-        <p:style>
-          <a:lnRef idx="1">
-            <a:schemeClr val="accent1"/>
-          </a:lnRef>
-          <a:fillRef idx="3">
-            <a:schemeClr val="accent1"/>
-          </a:fillRef>
-          <a:effectRef idx="2">
-            <a:schemeClr val="accent1"/>
-          </a:effectRef>
-          <a:fontRef idx="minor">
-            <a:schemeClr val="lt1"/>
-          </a:fontRef>
-        </p:style>
-        <p:txBody>
-          <a:bodyPr rtlCol="0" anchor="ctr" wrap="square"/>
-          <a:lstStyle/>
-          <a:p>
-            <a:pPr algn="ctr">
-              <a:defRPr sz="1600" b="1">
-                <a:solidFill>
-                  <a:srgbClr val="6366F1"/>
-                </a:solidFill>
-              </a:defRPr>
-            </a:pPr>
-            <a:r>
-              <a:t>5. Monitoreo Runtime</a:t>
-            </a:r>
-          </a:p>
-          <a:p>
+              <a:t>• Ejecutivos: Previene brechas costosas al corregir seguridad en etapas tempranas.</a:t>
+            </a:r>
             <a:br/>
-            <a:pPr>
-              <a:defRPr sz="1300">
-                <a:solidFill>
-                  <a:srgbClr val="F8FAFC"/>
-                </a:solidFill>
-              </a:defRPr>
-            </a:pPr>
-            <a:r>
-              <a:t>Wazuh EDR, Zeek NDR (conn.log), eBPF Tracing, Authentik ITDR.</a:t>
-            </a:r>
-          </a:p>
-        </p:txBody>
-      </p:sp>
-      <p:sp>
-        <p:nvSpPr>
-          <p:cNvPr id="9" name="Rounded Rectangle 8"/>
-          <p:cNvSpPr/>
-          <p:nvPr/>
-        </p:nvSpPr>
-        <p:spPr>
-          <a:xfrm>
-            <a:off x="7863840" y="3931920"/>
-            <a:ext cx="3383280" cy="2011680"/>
-          </a:xfrm>
-          <a:prstGeom prst="roundRect">
-            <a:avLst/>
-          </a:prstGeom>
-          <a:solidFill>
-            <a:srgbClr val="1E293B"/>
-          </a:solidFill>
-          <a:ln>
-            <a:solidFill>
-              <a:srgbClr val="334155"/>
-            </a:solidFill>
-          </a:ln>
-        </p:spPr>
-        <p:style>
-          <a:lnRef idx="1">
-            <a:schemeClr val="accent1"/>
-          </a:lnRef>
-          <a:fillRef idx="3">
-            <a:schemeClr val="accent1"/>
-          </a:fillRef>
-          <a:effectRef idx="2">
-            <a:schemeClr val="accent1"/>
-          </a:effectRef>
-          <a:fontRef idx="minor">
-            <a:schemeClr val="lt1"/>
-          </a:fontRef>
-        </p:style>
-        <p:txBody>
-          <a:bodyPr rtlCol="0" anchor="ctr" wrap="square"/>
-          <a:lstStyle/>
-          <a:p>
-            <a:pPr algn="ctr">
-              <a:defRPr sz="1600" b="1">
-                <a:solidFill>
-                  <a:srgbClr val="6366F1"/>
-                </a:solidFill>
-              </a:defRPr>
-            </a:pPr>
-            <a:r>
-              <a:t>6. Auto-Fix DevSecOps</a:t>
-            </a:r>
-          </a:p>
-          <a:p>
-            <a:br/>
-            <a:pPr>
-              <a:defRPr sz="1300">
-                <a:solidFill>
-                  <a:srgbClr val="F8FAFC"/>
-                </a:solidFill>
-              </a:defRPr>
-            </a:pPr>
-            <a:r>
-              <a:t>Parcheo determinístico y asistido por IA con integración a GitLab MR.</a:t>
+            <a:r>
+              <a:t>• Desarrolladores: Escaneo e integración de seguridad durante la codificación en GitLab.</a:t>
             </a:r>
           </a:p>
         </p:txBody>
@@ -4920,7 +5837,7 @@
               </a:defRPr>
             </a:pPr>
             <a:r>
-              <a:t>4. Estándares y Marcos Normativos Cubiertos</a:t>
+              <a:t>4. Glosario: Módulos de Ciberseguridad</a:t>
             </a:r>
           </a:p>
           <a:p>
@@ -4932,7 +5849,7 @@
               </a:defRPr>
             </a:pPr>
             <a:r>
-              <a:t>Mapeo automático de auditoría y cumplimiento corporativo</a:t>
+              <a:t>¿Qué significan las siglas principales en Centinela AI?</a:t>
             </a:r>
           </a:p>
         </p:txBody>
@@ -4979,27 +5896,31 @@
           <a:lstStyle/>
           <a:p>
             <a:pPr algn="ctr">
-              <a:defRPr sz="1600" b="1">
-                <a:solidFill>
-                  <a:srgbClr val="0EA5E9"/>
-                </a:solidFill>
-              </a:defRPr>
-            </a:pPr>
-            <a:r>
-              <a:t>STRIDE Threat Model</a:t>
+              <a:defRPr sz="1500" b="1">
+                <a:solidFill>
+                  <a:srgbClr val="6366F1"/>
+                </a:solidFill>
+              </a:defRPr>
+            </a:pPr>
+            <a:r>
+              <a:t>SAST &amp; SCA</a:t>
             </a:r>
           </a:p>
           <a:p>
             <a:br/>
             <a:pPr>
-              <a:defRPr sz="1300">
+              <a:defRPr sz="1200">
                 <a:solidFill>
                   <a:srgbClr val="F8FAFC"/>
                 </a:solidFill>
               </a:defRPr>
             </a:pPr>
             <a:r>
-              <a:t>Spoofing (JWT RS256/Ed25519 vs HS256), Tampering, Repudiation (bitácora inmutable), Information Disclosure, DoS y Elevation of Privilege.</a:t>
+              <a:t>• SAST: Pruebas estáticas de código fuente (SQLi, Secretos).</a:t>
+            </a:r>
+            <a:br/>
+            <a:r>
+              <a:t>• SCA: Análisis de vulnerabilidades en librerías Open Source.</a:t>
             </a:r>
           </a:p>
         </p:txBody>
@@ -5046,27 +5967,31 @@
           <a:lstStyle/>
           <a:p>
             <a:pPr algn="ctr">
-              <a:defRPr sz="1600" b="1">
-                <a:solidFill>
-                  <a:srgbClr val="0EA5E9"/>
-                </a:solidFill>
-              </a:defRPr>
-            </a:pPr>
-            <a:r>
-              <a:t>ISO/IEC 25010 &amp; ISO 27001</a:t>
+              <a:defRPr sz="1500" b="1">
+                <a:solidFill>
+                  <a:srgbClr val="6366F1"/>
+                </a:solidFill>
+              </a:defRPr>
+            </a:pPr>
+            <a:r>
+              <a:t>EDR &amp; NDR</a:t>
             </a:r>
           </a:p>
           <a:p>
             <a:br/>
             <a:pPr>
-              <a:defRPr sz="1300">
+              <a:defRPr sz="1200">
                 <a:solidFill>
                   <a:srgbClr val="F8FAFC"/>
                 </a:solidFill>
               </a:defRPr>
             </a:pPr>
             <a:r>
-              <a:t>Calidad de software (Complejidad Cognitiva &lt; 15) y Controles A.5.15 (Acceso), A.8.9 (Configuración), A.8.24 (Criptografía), A.8.28 (Codificación Segura).</a:t>
+              <a:t>• EDR: Agente en servidor/PC (Wazuh) para monitoreo de procesos.</a:t>
+            </a:r>
+            <a:br/>
+            <a:r>
+              <a:t>• NDR: Análisis continuo de tráfico de red (Zeek) ante ataques.</a:t>
             </a:r>
           </a:p>
         </p:txBody>
@@ -5113,27 +6038,31 @@
           <a:lstStyle/>
           <a:p>
             <a:pPr algn="ctr">
-              <a:defRPr sz="1600" b="1">
-                <a:solidFill>
-                  <a:srgbClr val="0EA5E9"/>
-                </a:solidFill>
-              </a:defRPr>
-            </a:pPr>
-            <a:r>
-              <a:t>NIST SP 800-53 &amp; PCI-DSS v4.0</a:t>
+              <a:defRPr sz="1500" b="1">
+                <a:solidFill>
+                  <a:srgbClr val="6366F1"/>
+                </a:solidFill>
+              </a:defRPr>
+            </a:pPr>
+            <a:r>
+              <a:t>ITDR &amp; XDR</a:t>
             </a:r>
           </a:p>
           <a:p>
             <a:br/>
             <a:pPr>
-              <a:defRPr sz="1300">
+              <a:defRPr sz="1200">
                 <a:solidFill>
                   <a:srgbClr val="F8FAFC"/>
                 </a:solidFill>
               </a:defRPr>
             </a:pPr>
             <a:r>
-              <a:t>Controles AC-3, CM-6, SI-10, AU-3, SC-8 / Requerimientos 2.2 (Hardening), 6.5.1 (Injection Flaws) y 10.2 (Auditoría Automatizada).</a:t>
+              <a:t>• ITDR: Detección de amenazas en capa de Identidad (Authentik/SSO).</a:t>
+            </a:r>
+            <a:br/>
+            <a:r>
+              <a:t>• XDR: Consola unificada que integra EDR + NDR + SAST + ITDR.</a:t>
             </a:r>
           </a:p>
         </p:txBody>
@@ -5180,27 +6109,31 @@
           <a:lstStyle/>
           <a:p>
             <a:pPr algn="ctr">
-              <a:defRPr sz="1600" b="1">
-                <a:solidFill>
-                  <a:srgbClr val="0EA5E9"/>
-                </a:solidFill>
-              </a:defRPr>
-            </a:pPr>
-            <a:r>
-              <a:t>SOC 2 Type II &amp; GDPR</a:t>
+              <a:defRPr sz="1500" b="1">
+                <a:solidFill>
+                  <a:srgbClr val="6366F1"/>
+                </a:solidFill>
+              </a:defRPr>
+            </a:pPr>
+            <a:r>
+              <a:t>DAST &amp; SOAR</a:t>
             </a:r>
           </a:p>
           <a:p>
             <a:br/>
             <a:pPr>
-              <a:defRPr sz="1300">
+              <a:defRPr sz="1200">
                 <a:solidFill>
                   <a:srgbClr val="F8FAFC"/>
                 </a:solidFill>
               </a:defRPr>
             </a:pPr>
             <a:r>
-              <a:t>Criterios CC6.1 (Acceso Lógico), CC6.8 (Hardening), CC7.2 (Monitoreo) y Cumplimiento Art. 30/32 (Registro de Actividades y Cifrado PII).</a:t>
+              <a:t>• DAST: Pruebas dinámicas en runtime desde la red.</a:t>
+            </a:r>
+            <a:br/>
+            <a:r>
+              <a:t>• SOAR: Automatización y respuesta a incidentes en tiempo real.</a:t>
             </a:r>
           </a:p>
         </p:txBody>
@@ -5298,7 +6231,7 @@
               </a:defRPr>
             </a:pPr>
             <a:r>
-              <a:t>5. Taxonomía de Hallazgos y Amenazas Cubiertas</a:t>
+              <a:t>5. Glosario: Métricas y Priorización de Riesgo</a:t>
             </a:r>
           </a:p>
           <a:p>
@@ -5310,7 +6243,7 @@
               </a:defRPr>
             </a:pPr>
             <a:r>
-              <a:t>Identificación y trazabilidad de vectores de ataque por motor</a:t>
+              <a:t>¿Cómo prioriza Centinela las vulnerabilidades reales?</a:t>
             </a:r>
           </a:p>
         </p:txBody>
@@ -5323,8 +6256,8 @@
         </p:nvSpPr>
         <p:spPr>
           <a:xfrm>
-            <a:off x="731520" y="1645920"/>
-            <a:ext cx="3383280" cy="2011680"/>
+            <a:off x="731520" y="1554480"/>
+            <a:ext cx="5212080" cy="2103120"/>
           </a:xfrm>
           <a:prstGeom prst="roundRect">
             <a:avLst/>
@@ -5359,12 +6292,12 @@
             <a:pPr algn="ctr">
               <a:defRPr sz="1500" b="1">
                 <a:solidFill>
-                  <a:srgbClr val="6366F1"/>
-                </a:solidFill>
-              </a:defRPr>
-            </a:pPr>
-            <a:r>
-              <a:t>ZAP-NNNNN</a:t>
+                  <a:srgbClr val="0EA5E9"/>
+                </a:solidFill>
+              </a:defRPr>
+            </a:pPr>
+            <a:r>
+              <a:t>CVE (Common Vulnerabilities &amp; Exposures)</a:t>
             </a:r>
           </a:p>
           <a:p>
@@ -5377,7 +6310,7 @@
               </a:defRPr>
             </a:pPr>
             <a:r>
-              <a:t>Plugin ID oficial OWASP ZAP (ej: ZAP-10015 Incomplete Cache-Control, cabeceras ausentes, XSS).</a:t>
+              <a:t>Identificador universal único asignado a un fallo de seguridad conocido mundialmente (ej. CVE-2024-29041).</a:t>
             </a:r>
           </a:p>
         </p:txBody>
@@ -5390,8 +6323,8 @@
         </p:nvSpPr>
         <p:spPr>
           <a:xfrm>
-            <a:off x="4297680" y="1645920"/>
-            <a:ext cx="3383280" cy="2011680"/>
+            <a:off x="6126480" y="1554480"/>
+            <a:ext cx="5212080" cy="2103120"/>
           </a:xfrm>
           <a:prstGeom prst="roundRect">
             <a:avLst/>
@@ -5426,12 +6359,12 @@
             <a:pPr algn="ctr">
               <a:defRPr sz="1500" b="1">
                 <a:solidFill>
-                  <a:srgbClr val="6366F1"/>
-                </a:solidFill>
-              </a:defRPr>
-            </a:pPr>
-            <a:r>
-              <a:t>SCA-CVE-YYYY-NNNNN</a:t>
+                  <a:srgbClr val="0EA5E9"/>
+                </a:solidFill>
+              </a:defRPr>
+            </a:pPr>
+            <a:r>
+              <a:t>CVSS (Common Vulnerability Scoring System)</a:t>
             </a:r>
           </a:p>
           <a:p>
@@ -5444,7 +6377,7 @@
               </a:defRPr>
             </a:pPr>
             <a:r>
-              <a:t>Vulnerabilidades en dependencias sincronizadas en vivo con OSV.dev (ej: Express, PyYAML).</a:t>
+              <a:t>Escala técnica global del 0 al 10 que mide la gravedad teórica del impacto de una vulnerabilidad.</a:t>
             </a:r>
           </a:p>
         </p:txBody>
@@ -5457,8 +6390,8 @@
         </p:nvSpPr>
         <p:spPr>
           <a:xfrm>
-            <a:off x="7863840" y="1645920"/>
-            <a:ext cx="3383280" cy="2011680"/>
+            <a:off x="731520" y="3840480"/>
+            <a:ext cx="5212080" cy="2103120"/>
           </a:xfrm>
           <a:prstGeom prst="roundRect">
             <a:avLst/>
@@ -5493,12 +6426,12 @@
             <a:pPr algn="ctr">
               <a:defRPr sz="1500" b="1">
                 <a:solidFill>
-                  <a:srgbClr val="6366F1"/>
-                </a:solidFill>
-              </a:defRPr>
-            </a:pPr>
-            <a:r>
-              <a:t>CODE / CMD / SQL / SSRF</a:t>
+                  <a:srgbClr val="22C55E"/>
+                </a:solidFill>
+              </a:defRPr>
+            </a:pPr>
+            <a:r>
+              <a:t>EPSS (Exploit Prediction Scoring System)</a:t>
             </a:r>
           </a:p>
           <a:p>
@@ -5511,7 +6444,7 @@
               </a:defRPr>
             </a:pPr>
             <a:r>
-              <a:t>Reglas del motor SAST nativo (ej: CODE-INJECTION-EVAL, concatenación de SQL dinámico).</a:t>
+              <a:t>Porcentaje (0-100%) que predice la probabilidad real de que un atacante intente explotar la falla en los próximos 30 días.</a:t>
             </a:r>
           </a:p>
         </p:txBody>
@@ -5524,8 +6457,8 @@
         </p:nvSpPr>
         <p:spPr>
           <a:xfrm>
-            <a:off x="731520" y="3931920"/>
-            <a:ext cx="3383280" cy="2011680"/>
+            <a:off x="6126480" y="3840480"/>
+            <a:ext cx="5212080" cy="2103120"/>
           </a:xfrm>
           <a:prstGeom prst="roundRect">
             <a:avLst/>
@@ -5560,12 +6493,12 @@
             <a:pPr algn="ctr">
               <a:defRPr sz="1500" b="1">
                 <a:solidFill>
-                  <a:srgbClr val="6366F1"/>
-                </a:solidFill>
-              </a:defRPr>
-            </a:pPr>
-            <a:r>
-              <a:t>DOCKER / IaC</a:t>
+                  <a:srgbClr val="0EA5E9"/>
+                </a:solidFill>
+              </a:defRPr>
+            </a:pPr>
+            <a:r>
+              <a:t>CISA KEV (Known Exploited Vulnerabilities)</a:t>
             </a:r>
           </a:p>
           <a:p>
@@ -5578,141 +6511,7 @@
               </a:defRPr>
             </a:pPr>
             <a:r>
-              <a:t>Hardening de infraestructura (ej: DOCKER-MISSING-NON-ROOT-USER, buckets S3 públicos).</a:t>
-            </a:r>
-          </a:p>
-        </p:txBody>
-      </p:sp>
-      <p:sp>
-        <p:nvSpPr>
-          <p:cNvPr id="8" name="Rounded Rectangle 7"/>
-          <p:cNvSpPr/>
-          <p:nvPr/>
-        </p:nvSpPr>
-        <p:spPr>
-          <a:xfrm>
-            <a:off x="4297680" y="3931920"/>
-            <a:ext cx="3383280" cy="2011680"/>
-          </a:xfrm>
-          <a:prstGeom prst="roundRect">
-            <a:avLst/>
-          </a:prstGeom>
-          <a:solidFill>
-            <a:srgbClr val="1E293B"/>
-          </a:solidFill>
-          <a:ln>
-            <a:solidFill>
-              <a:srgbClr val="334155"/>
-            </a:solidFill>
-          </a:ln>
-        </p:spPr>
-        <p:style>
-          <a:lnRef idx="1">
-            <a:schemeClr val="accent1"/>
-          </a:lnRef>
-          <a:fillRef idx="3">
-            <a:schemeClr val="accent1"/>
-          </a:fillRef>
-          <a:effectRef idx="2">
-            <a:schemeClr val="accent1"/>
-          </a:effectRef>
-          <a:fontRef idx="minor">
-            <a:schemeClr val="lt1"/>
-          </a:fontRef>
-        </p:style>
-        <p:txBody>
-          <a:bodyPr rtlCol="0" anchor="ctr" wrap="square"/>
-          <a:lstStyle/>
-          <a:p>
-            <a:pPr algn="ctr">
-              <a:defRPr sz="1500" b="1">
-                <a:solidFill>
-                  <a:srgbClr val="6366F1"/>
-                </a:solidFill>
-              </a:defRPr>
-            </a:pPr>
-            <a:r>
-              <a:t>STD-STRIDE / ISO25010</a:t>
-            </a:r>
-          </a:p>
-          <a:p>
-            <a:br/>
-            <a:pPr>
-              <a:defRPr sz="1200">
-                <a:solidFill>
-                  <a:srgbClr val="F8FAFC"/>
-                </a:solidFill>
-              </a:defRPr>
-            </a:pPr>
-            <a:r>
-              <a:t>Violaciones arquitectónicas y calidad de software (ej: STD-STRIDE-JWT-INSECURE-ALG).</a:t>
-            </a:r>
-          </a:p>
-        </p:txBody>
-      </p:sp>
-      <p:sp>
-        <p:nvSpPr>
-          <p:cNvPr id="9" name="Rounded Rectangle 8"/>
-          <p:cNvSpPr/>
-          <p:nvPr/>
-        </p:nvSpPr>
-        <p:spPr>
-          <a:xfrm>
-            <a:off x="7863840" y="3931920"/>
-            <a:ext cx="3383280" cy="2011680"/>
-          </a:xfrm>
-          <a:prstGeom prst="roundRect">
-            <a:avLst/>
-          </a:prstGeom>
-          <a:solidFill>
-            <a:srgbClr val="1E293B"/>
-          </a:solidFill>
-          <a:ln>
-            <a:solidFill>
-              <a:srgbClr val="334155"/>
-            </a:solidFill>
-          </a:ln>
-        </p:spPr>
-        <p:style>
-          <a:lnRef idx="1">
-            <a:schemeClr val="accent1"/>
-          </a:lnRef>
-          <a:fillRef idx="3">
-            <a:schemeClr val="accent1"/>
-          </a:fillRef>
-          <a:effectRef idx="2">
-            <a:schemeClr val="accent1"/>
-          </a:effectRef>
-          <a:fontRef idx="minor">
-            <a:schemeClr val="lt1"/>
-          </a:fontRef>
-        </p:style>
-        <p:txBody>
-          <a:bodyPr rtlCol="0" anchor="ctr" wrap="square"/>
-          <a:lstStyle/>
-          <a:p>
-            <a:pPr algn="ctr">
-              <a:defRPr sz="1500" b="1">
-                <a:solidFill>
-                  <a:srgbClr val="6366F1"/>
-                </a:solidFill>
-              </a:defRPr>
-            </a:pPr>
-            <a:r>
-              <a:t>CTI-IOC / ITDR / eBPF</a:t>
-            </a:r>
-          </a:p>
-          <a:p>
-            <a:br/>
-            <a:pPr>
-              <a:defRPr sz="1200">
-                <a:solidFill>
-                  <a:srgbClr val="F8FAFC"/>
-                </a:solidFill>
-              </a:defRPr>
-            </a:pPr>
-            <a:r>
-              <a:t>Vectores runtime (Password Spraying en Authentik, C2 IPs activas de Feodo Tracker, syscalls Linux).</a:t>
+              <a:t>Catálogo del gobierno de EE.UU. que confirma que una vulnerabilidad ya está siendo atacada activamente en el mundo real.</a:t>
             </a:r>
           </a:p>
         </p:txBody>
@@ -5810,7 +6609,7 @@
               </a:defRPr>
             </a:pPr>
             <a:r>
-              <a:t>6. Correlación de Riesgo (CRS) y Motor IA</a:t>
+              <a:t>6. Cobertura de Seguridad (6 Pilares)</a:t>
             </a:r>
           </a:p>
           <a:p>
@@ -5822,7 +6621,7 @@
               </a:defRPr>
             </a:pPr>
             <a:r>
-              <a:t>Cálculo de criticidad y resiliencia multi-proveedor de LLM</a:t>
+              <a:t>¿Qué audita el sistema?</a:t>
             </a:r>
           </a:p>
         </p:txBody>
@@ -5836,7 +6635,7 @@
         <p:spPr>
           <a:xfrm>
             <a:off x="731520" y="1645920"/>
-            <a:ext cx="3383280" cy="4389120"/>
+            <a:ext cx="3383280" cy="2011680"/>
           </a:xfrm>
           <a:prstGeom prst="roundRect">
             <a:avLst/>
@@ -5869,14 +6668,14 @@
           <a:lstStyle/>
           <a:p>
             <a:pPr algn="ctr">
-              <a:defRPr sz="1700" b="1">
-                <a:solidFill>
-                  <a:srgbClr val="0EA5E9"/>
-                </a:solidFill>
-              </a:defRPr>
-            </a:pPr>
-            <a:r>
-              <a:t>Centinela Risk Score (CRS)</a:t>
+              <a:defRPr sz="1600" b="1">
+                <a:solidFill>
+                  <a:srgbClr val="6366F1"/>
+                </a:solidFill>
+              </a:defRPr>
+            </a:pPr>
+            <a:r>
+              <a:t>1. SAST &amp; Clean Code</a:t>
             </a:r>
           </a:p>
           <a:p>
@@ -5889,7 +6688,7 @@
               </a:defRPr>
             </a:pPr>
             <a:r>
-              <a:t>Puntuación 0-100 por hallazgo. Combina la severidad CVSS con probabilidad de explotación real (EPSS de FIRST.org en vivo), CISA KEV (ataques confirmados en el mundo) y la criticidad del activo.</a:t>
+              <a:t>Motor AST nativo + Semgrep (SQLi, CMD Injection, SSRF, Secretos, ISO 25010).</a:t>
             </a:r>
           </a:p>
         </p:txBody>
@@ -5903,7 +6702,7 @@
         <p:spPr>
           <a:xfrm>
             <a:off x="4297680" y="1645920"/>
-            <a:ext cx="3383280" cy="4389120"/>
+            <a:ext cx="3383280" cy="2011680"/>
           </a:xfrm>
           <a:prstGeom prst="roundRect">
             <a:avLst/>
@@ -5936,14 +6735,14 @@
           <a:lstStyle/>
           <a:p>
             <a:pPr algn="ctr">
-              <a:defRPr sz="1700" b="1">
-                <a:solidFill>
-                  <a:srgbClr val="0EA5E9"/>
-                </a:solidFill>
-              </a:defRPr>
-            </a:pPr>
-            <a:r>
-              <a:t>Cadena Multi-Proveedor LLM</a:t>
+              <a:defRPr sz="1600" b="1">
+                <a:solidFill>
+                  <a:srgbClr val="6366F1"/>
+                </a:solidFill>
+              </a:defRPr>
+            </a:pPr>
+            <a:r>
+              <a:t>2. SCA &amp; Dependencias</a:t>
             </a:r>
           </a:p>
           <a:p>
@@ -5956,15 +6755,7 @@
               </a:defRPr>
             </a:pPr>
             <a:r>
-              <a:t>Cadena de resiliencia con fallback automático en cada llamada:</a:t>
-            </a:r>
-            <a:br/>
-            <a:r>
-              <a:t>Groq → Google Gemini → NVIDIA NIM → OpenRouter → Motor Heurístico Determinístico.</a:t>
-            </a:r>
-            <a:br/>
-            <a:r>
-              <a:t>Garantiza disponibilidad constante si una API agota cuota.</a:t>
+              <a:t>Escaneo de paquetes npm/pip en vivo contra OSV.dev con análisis de alcanzabilidad.</a:t>
             </a:r>
           </a:p>
         </p:txBody>
@@ -5978,7 +6769,7 @@
         <p:spPr>
           <a:xfrm>
             <a:off x="7863840" y="1645920"/>
-            <a:ext cx="3383280" cy="4389120"/>
+            <a:ext cx="3383280" cy="2011680"/>
           </a:xfrm>
           <a:prstGeom prst="roundRect">
             <a:avLst/>
@@ -6011,14 +6802,14 @@
           <a:lstStyle/>
           <a:p>
             <a:pPr algn="ctr">
-              <a:defRPr sz="1700" b="1">
-                <a:solidFill>
-                  <a:srgbClr val="0EA5E9"/>
-                </a:solidFill>
-              </a:defRPr>
-            </a:pPr>
-            <a:r>
-              <a:t>Validación Estricta de Parches</a:t>
+              <a:defRPr sz="1600" b="1">
+                <a:solidFill>
+                  <a:srgbClr val="6366F1"/>
+                </a:solidFill>
+              </a:defRPr>
+            </a:pPr>
+            <a:r>
+              <a:t>3. Hardening &amp; IaC</a:t>
             </a:r>
           </a:p>
           <a:p>
@@ -6031,7 +6822,208 @@
               </a:defRPr>
             </a:pPr>
             <a:r>
-              <a:t>La IA genera diffs unificados (`git apply`) o scripts Bash. Centinela valida que la respuesta no sea texto de relleno (`... script provisto`); si la calidad es baja, cae automáticamente al motor determinístico.</a:t>
+              <a:t>Checkov (Terraform/K8s), Dockerfiles no-root y CIS Benchmarks Linux SSH.</a:t>
+            </a:r>
+          </a:p>
+        </p:txBody>
+      </p:sp>
+      <p:sp>
+        <p:nvSpPr>
+          <p:cNvPr id="7" name="Rounded Rectangle 6"/>
+          <p:cNvSpPr/>
+          <p:nvPr/>
+        </p:nvSpPr>
+        <p:spPr>
+          <a:xfrm>
+            <a:off x="731520" y="3931920"/>
+            <a:ext cx="3383280" cy="2011680"/>
+          </a:xfrm>
+          <a:prstGeom prst="roundRect">
+            <a:avLst/>
+          </a:prstGeom>
+          <a:solidFill>
+            <a:srgbClr val="1E293B"/>
+          </a:solidFill>
+          <a:ln>
+            <a:solidFill>
+              <a:srgbClr val="334155"/>
+            </a:solidFill>
+          </a:ln>
+        </p:spPr>
+        <p:style>
+          <a:lnRef idx="1">
+            <a:schemeClr val="accent1"/>
+          </a:lnRef>
+          <a:fillRef idx="3">
+            <a:schemeClr val="accent1"/>
+          </a:fillRef>
+          <a:effectRef idx="2">
+            <a:schemeClr val="accent1"/>
+          </a:effectRef>
+          <a:fontRef idx="minor">
+            <a:schemeClr val="lt1"/>
+          </a:fontRef>
+        </p:style>
+        <p:txBody>
+          <a:bodyPr rtlCol="0" anchor="ctr" wrap="square"/>
+          <a:lstStyle/>
+          <a:p>
+            <a:pPr algn="ctr">
+              <a:defRPr sz="1600" b="1">
+                <a:solidFill>
+                  <a:srgbClr val="6366F1"/>
+                </a:solidFill>
+              </a:defRPr>
+            </a:pPr>
+            <a:r>
+              <a:t>4. Gobernanza de IA</a:t>
+            </a:r>
+          </a:p>
+          <a:p>
+            <a:br/>
+            <a:pPr>
+              <a:defRPr sz="1300">
+                <a:solidFill>
+                  <a:srgbClr val="F8FAFC"/>
+                </a:solidFill>
+              </a:defRPr>
+            </a:pPr>
+            <a:r>
+              <a:t>OWASP LLM Top 10 via Medusa-Security (Prompt Injection, fuga de PII).</a:t>
+            </a:r>
+          </a:p>
+        </p:txBody>
+      </p:sp>
+      <p:sp>
+        <p:nvSpPr>
+          <p:cNvPr id="8" name="Rounded Rectangle 7"/>
+          <p:cNvSpPr/>
+          <p:nvPr/>
+        </p:nvSpPr>
+        <p:spPr>
+          <a:xfrm>
+            <a:off x="4297680" y="3931920"/>
+            <a:ext cx="3383280" cy="2011680"/>
+          </a:xfrm>
+          <a:prstGeom prst="roundRect">
+            <a:avLst/>
+          </a:prstGeom>
+          <a:solidFill>
+            <a:srgbClr val="1E293B"/>
+          </a:solidFill>
+          <a:ln>
+            <a:solidFill>
+              <a:srgbClr val="334155"/>
+            </a:solidFill>
+          </a:ln>
+        </p:spPr>
+        <p:style>
+          <a:lnRef idx="1">
+            <a:schemeClr val="accent1"/>
+          </a:lnRef>
+          <a:fillRef idx="3">
+            <a:schemeClr val="accent1"/>
+          </a:fillRef>
+          <a:effectRef idx="2">
+            <a:schemeClr val="accent1"/>
+          </a:effectRef>
+          <a:fontRef idx="minor">
+            <a:schemeClr val="lt1"/>
+          </a:fontRef>
+        </p:style>
+        <p:txBody>
+          <a:bodyPr rtlCol="0" anchor="ctr" wrap="square"/>
+          <a:lstStyle/>
+          <a:p>
+            <a:pPr algn="ctr">
+              <a:defRPr sz="1600" b="1">
+                <a:solidFill>
+                  <a:srgbClr val="6366F1"/>
+                </a:solidFill>
+              </a:defRPr>
+            </a:pPr>
+            <a:r>
+              <a:t>5. Monitoreo Runtime</a:t>
+            </a:r>
+          </a:p>
+          <a:p>
+            <a:br/>
+            <a:pPr>
+              <a:defRPr sz="1300">
+                <a:solidFill>
+                  <a:srgbClr val="F8FAFC"/>
+                </a:solidFill>
+              </a:defRPr>
+            </a:pPr>
+            <a:r>
+              <a:t>Wazuh EDR, Zeek NDR (conn.log), eBPF Tracing, Authentik ITDR.</a:t>
+            </a:r>
+          </a:p>
+        </p:txBody>
+      </p:sp>
+      <p:sp>
+        <p:nvSpPr>
+          <p:cNvPr id="9" name="Rounded Rectangle 8"/>
+          <p:cNvSpPr/>
+          <p:nvPr/>
+        </p:nvSpPr>
+        <p:spPr>
+          <a:xfrm>
+            <a:off x="7863840" y="3931920"/>
+            <a:ext cx="3383280" cy="2011680"/>
+          </a:xfrm>
+          <a:prstGeom prst="roundRect">
+            <a:avLst/>
+          </a:prstGeom>
+          <a:solidFill>
+            <a:srgbClr val="1E293B"/>
+          </a:solidFill>
+          <a:ln>
+            <a:solidFill>
+              <a:srgbClr val="334155"/>
+            </a:solidFill>
+          </a:ln>
+        </p:spPr>
+        <p:style>
+          <a:lnRef idx="1">
+            <a:schemeClr val="accent1"/>
+          </a:lnRef>
+          <a:fillRef idx="3">
+            <a:schemeClr val="accent1"/>
+          </a:fillRef>
+          <a:effectRef idx="2">
+            <a:schemeClr val="accent1"/>
+          </a:effectRef>
+          <a:fontRef idx="minor">
+            <a:schemeClr val="lt1"/>
+          </a:fontRef>
+        </p:style>
+        <p:txBody>
+          <a:bodyPr rtlCol="0" anchor="ctr" wrap="square"/>
+          <a:lstStyle/>
+          <a:p>
+            <a:pPr algn="ctr">
+              <a:defRPr sz="1600" b="1">
+                <a:solidFill>
+                  <a:srgbClr val="6366F1"/>
+                </a:solidFill>
+              </a:defRPr>
+            </a:pPr>
+            <a:r>
+              <a:t>6. Auto-Fix DevSecOps</a:t>
+            </a:r>
+          </a:p>
+          <a:p>
+            <a:br/>
+            <a:pPr>
+              <a:defRPr sz="1300">
+                <a:solidFill>
+                  <a:srgbClr val="F8FAFC"/>
+                </a:solidFill>
+              </a:defRPr>
+            </a:pPr>
+            <a:r>
+              <a:t>Parcheo determinístico y asistido por IA con integración a GitLab MR.</a:t>
             </a:r>
           </a:p>
         </p:txBody>
@@ -6129,7 +7121,7 @@
               </a:defRPr>
             </a:pPr>
             <a:r>
-              <a:t>7. Funcionamiento del SOAR 2.0 y Remediación</a:t>
+              <a:t>4. Estándares y Marcos Normativos Cubiertos</a:t>
             </a:r>
           </a:p>
           <a:p>
@@ -6141,7 +7133,7 @@
               </a:defRPr>
             </a:pPr>
             <a:r>
-              <a:t>Flujo de ejecución defensiva automatizada con Human-in-the-Loop</a:t>
+              <a:t>Mapeo automático de auditoría y cumplimiento corporativo</a:t>
             </a:r>
           </a:p>
         </p:txBody>
@@ -6190,12 +7182,12 @@
             <a:pPr algn="ctr">
               <a:defRPr sz="1600" b="1">
                 <a:solidFill>
-                  <a:srgbClr val="22C55E"/>
-                </a:solidFill>
-              </a:defRPr>
-            </a:pPr>
-            <a:r>
-              <a:t>1. Evaluación de Confianza</a:t>
+                  <a:srgbClr val="0EA5E9"/>
+                </a:solidFill>
+              </a:defRPr>
+            </a:pPr>
+            <a:r>
+              <a:t>STRIDE Threat Model</a:t>
             </a:r>
           </a:p>
           <a:p>
@@ -6208,7 +7200,7 @@
               </a:defRPr>
             </a:pPr>
             <a:r>
-              <a:t>Si la confianza del parche es ≥95% (Virtual Patching Nginx / Revocación Authentik), se ejecuta respuesta inmediata. Si es &lt;95%, requiere aprobación 1-click.</a:t>
+              <a:t>Spoofing (JWT RS256/Ed25519 vs HS256), Tampering, Repudiation (bitácora inmutable), Information Disclosure, DoS y Elevation of Privilege.</a:t>
             </a:r>
           </a:p>
         </p:txBody>
@@ -6257,12 +7249,12 @@
             <a:pPr algn="ctr">
               <a:defRPr sz="1600" b="1">
                 <a:solidFill>
-                  <a:srgbClr val="22C55E"/>
-                </a:solidFill>
-              </a:defRPr>
-            </a:pPr>
-            <a:r>
-              <a:t>2. Remediación en Servidores</a:t>
+                  <a:srgbClr val="0EA5E9"/>
+                </a:solidFill>
+              </a:defRPr>
+            </a:pPr>
+            <a:r>
+              <a:t>ISO/IEC 25010 &amp; ISO 27001</a:t>
             </a:r>
           </a:p>
           <a:p>
@@ -6275,7 +7267,7 @@
               </a:defRPr>
             </a:pPr>
             <a:r>
-              <a:t>Sentinel se autentica vía Vault (credenciales SSH/sudo dedicadas `NOPASSWD` acotadas) y ejecuta Playbooks de Ansible. Si el comando falla, el estado se marca `FAILED`.</a:t>
+              <a:t>Calidad de software (Complejidad Cognitiva &lt; 15) y Controles A.5.15 (Acceso), A.8.9 (Configuración), A.8.24 (Criptografía), A.8.28 (Codificación Segura).</a:t>
             </a:r>
           </a:p>
         </p:txBody>
@@ -6324,12 +7316,12 @@
             <a:pPr algn="ctr">
               <a:defRPr sz="1600" b="1">
                 <a:solidFill>
-                  <a:srgbClr val="22C55E"/>
-                </a:solidFill>
-              </a:defRPr>
-            </a:pPr>
-            <a:r>
-              <a:t>3. Remediación en GitLab</a:t>
+                  <a:srgbClr val="0EA5E9"/>
+                </a:solidFill>
+              </a:defRPr>
+            </a:pPr>
+            <a:r>
+              <a:t>NIST SP 800-53 &amp; PCI-DSS v4.0</a:t>
             </a:r>
           </a:p>
           <a:p>
@@ -6342,7 +7334,7 @@
               </a:defRPr>
             </a:pPr>
             <a:r>
-              <a:t>Sentinel clona el repositorio, aplica el diff unificado en una rama `centinela-fix/*` y abre un Merge Request formal con detalles normativos. NUNCA hace push directo a main.</a:t>
+              <a:t>Controles AC-3, CM-6, SI-10, AU-3, SC-8 / Requerimientos 2.2 (Hardening), 6.5.1 (Injection Flaws) y 10.2 (Auditoría Automatizada).</a:t>
             </a:r>
           </a:p>
         </p:txBody>
@@ -6391,12 +7383,12 @@
             <a:pPr algn="ctr">
               <a:defRPr sz="1600" b="1">
                 <a:solidFill>
-                  <a:srgbClr val="22C55E"/>
-                </a:solidFill>
-              </a:defRPr>
-            </a:pPr>
-            <a:r>
-              <a:t>4. Trazabilidad Inmutable</a:t>
+                  <a:srgbClr val="0EA5E9"/>
+                </a:solidFill>
+              </a:defRPr>
+            </a:pPr>
+            <a:r>
+              <a:t>SOC 2 Type II &amp; GDPR</a:t>
             </a:r>
           </a:p>
           <a:p>
@@ -6409,7 +7401,7 @@
               </a:defRPr>
             </a:pPr>
             <a:r>
-              <a:t>Todo evento de remediación se registra en PostgreSQL y auditoría STRIDE, garantizando no-repudio y visibilidad completa para los auditores de seguridad.</a:t>
+              <a:t>Criterios CC6.1 (Acceso Lógico), CC6.8 (Hardening), CC7.2 (Monitoreo) y Cumplimiento Art. 30/32 (Registro de Actividades y Cifrado PII).</a:t>
             </a:r>
           </a:p>
         </p:txBody>
@@ -6507,7 +7499,7 @@
               </a:defRPr>
             </a:pPr>
             <a:r>
-              <a:t>8. Beneficios Organizacionales</a:t>
+              <a:t>5. Taxonomía de Hallazgos y Amenazas Cubiertas</a:t>
             </a:r>
           </a:p>
           <a:p>
@@ -6519,7 +7511,7 @@
               </a:defRPr>
             </a:pPr>
             <a:r>
-              <a:t>¿Qué aporta su uso a cada rol en la empresa?</a:t>
+              <a:t>Identificación y trazabilidad de vectores de ataque por motor</a:t>
             </a:r>
           </a:p>
         </p:txBody>
@@ -6533,7 +7525,7 @@
         <p:spPr>
           <a:xfrm>
             <a:off x="731520" y="1645920"/>
-            <a:ext cx="3383280" cy="4389120"/>
+            <a:ext cx="3383280" cy="2011680"/>
           </a:xfrm>
           <a:prstGeom prst="roundRect">
             <a:avLst/>
@@ -6566,35 +7558,27 @@
           <a:lstStyle/>
           <a:p>
             <a:pPr algn="ctr">
-              <a:defRPr sz="1600" b="1">
-                <a:solidFill>
-                  <a:srgbClr val="0EA5E9"/>
-                </a:solidFill>
-              </a:defRPr>
-            </a:pPr>
-            <a:r>
-              <a:t>👔 Para la Dirección / C-Level</a:t>
+              <a:defRPr sz="1500" b="1">
+                <a:solidFill>
+                  <a:srgbClr val="6366F1"/>
+                </a:solidFill>
+              </a:defRPr>
+            </a:pPr>
+            <a:r>
+              <a:t>ZAP-NNNNN</a:t>
             </a:r>
           </a:p>
           <a:p>
             <a:br/>
             <a:pPr>
-              <a:defRPr sz="1300">
+              <a:defRPr sz="1200">
                 <a:solidFill>
                   <a:srgbClr val="F8FAFC"/>
                 </a:solidFill>
               </a:defRPr>
             </a:pPr>
             <a:r>
-              <a:t>• Reducción radical del riesgo de brechas.</a:t>
-            </a:r>
-            <a:br/>
-            <a:r>
-              <a:t>• Ahorro directo por consolidación de herramientas.</a:t>
-            </a:r>
-            <a:br/>
-            <a:r>
-              <a:t>• Reportes ejecutivos de cumplimiento (ISO/NIST/PCI).</a:t>
+              <a:t>Plugin ID oficial OWASP ZAP (ej: ZAP-10015 Incomplete Cache-Control, cabeceras ausentes, XSS).</a:t>
             </a:r>
           </a:p>
         </p:txBody>
@@ -6608,7 +7592,7 @@
         <p:spPr>
           <a:xfrm>
             <a:off x="4297680" y="1645920"/>
-            <a:ext cx="3383280" cy="4389120"/>
+            <a:ext cx="3383280" cy="2011680"/>
           </a:xfrm>
           <a:prstGeom prst="roundRect">
             <a:avLst/>
@@ -6641,35 +7625,27 @@
           <a:lstStyle/>
           <a:p>
             <a:pPr algn="ctr">
-              <a:defRPr sz="1600" b="1">
+              <a:defRPr sz="1500" b="1">
                 <a:solidFill>
                   <a:srgbClr val="6366F1"/>
                 </a:solidFill>
               </a:defRPr>
             </a:pPr>
             <a:r>
-              <a:t>🛡️ Para Líder de Equipo / SOC</a:t>
+              <a:t>SCA-CVE-YYYY-NNNNN</a:t>
             </a:r>
           </a:p>
           <a:p>
             <a:br/>
             <a:pPr>
-              <a:defRPr sz="1300">
+              <a:defRPr sz="1200">
                 <a:solidFill>
                   <a:srgbClr val="F8FAFC"/>
                 </a:solidFill>
               </a:defRPr>
             </a:pPr>
             <a:r>
-              <a:t>• Tablero unificado Single-Pane-of-Glass.</a:t>
-            </a:r>
-            <a:br/>
-            <a:r>
-              <a:t>• Priorización basada en riesgo real (EPSS/KEV).</a:t>
-            </a:r>
-            <a:br/>
-            <a:r>
-              <a:t>• Quality Gates para pipelines CI/CD.</a:t>
+              <a:t>Vulnerabilidades en dependencias sincronizadas en vivo con OSV.dev (ej: Express, PyYAML).</a:t>
             </a:r>
           </a:p>
         </p:txBody>
@@ -6683,7 +7659,7 @@
         <p:spPr>
           <a:xfrm>
             <a:off x="7863840" y="1645920"/>
-            <a:ext cx="3383280" cy="4389120"/>
+            <a:ext cx="3383280" cy="2011680"/>
           </a:xfrm>
           <a:prstGeom prst="roundRect">
             <a:avLst/>
@@ -6716,35 +7692,228 @@
           <a:lstStyle/>
           <a:p>
             <a:pPr algn="ctr">
-              <a:defRPr sz="1600" b="1">
-                <a:solidFill>
-                  <a:srgbClr val="0EA5E9"/>
-                </a:solidFill>
-              </a:defRPr>
-            </a:pPr>
-            <a:r>
-              <a:t>💻 Para el Equipo de Desarrollo</a:t>
+              <a:defRPr sz="1500" b="1">
+                <a:solidFill>
+                  <a:srgbClr val="6366F1"/>
+                </a:solidFill>
+              </a:defRPr>
+            </a:pPr>
+            <a:r>
+              <a:t>CODE / CMD / SQL / SSRF</a:t>
             </a:r>
           </a:p>
           <a:p>
             <a:br/>
             <a:pPr>
-              <a:defRPr sz="1300">
+              <a:defRPr sz="1200">
                 <a:solidFill>
                   <a:srgbClr val="F8FAFC"/>
                 </a:solidFill>
               </a:defRPr>
             </a:pPr>
             <a:r>
-              <a:t>• Fricción cero: Parches mediante MRs formales.</a:t>
-            </a:r>
+              <a:t>Reglas del motor SAST nativo (ej: CODE-INJECTION-EVAL, concatenación de SQL dinámico).</a:t>
+            </a:r>
+          </a:p>
+        </p:txBody>
+      </p:sp>
+      <p:sp>
+        <p:nvSpPr>
+          <p:cNvPr id="7" name="Rounded Rectangle 6"/>
+          <p:cNvSpPr/>
+          <p:nvPr/>
+        </p:nvSpPr>
+        <p:spPr>
+          <a:xfrm>
+            <a:off x="731520" y="3931920"/>
+            <a:ext cx="3383280" cy="2011680"/>
+          </a:xfrm>
+          <a:prstGeom prst="roundRect">
+            <a:avLst/>
+          </a:prstGeom>
+          <a:solidFill>
+            <a:srgbClr val="1E293B"/>
+          </a:solidFill>
+          <a:ln>
+            <a:solidFill>
+              <a:srgbClr val="334155"/>
+            </a:solidFill>
+          </a:ln>
+        </p:spPr>
+        <p:style>
+          <a:lnRef idx="1">
+            <a:schemeClr val="accent1"/>
+          </a:lnRef>
+          <a:fillRef idx="3">
+            <a:schemeClr val="accent1"/>
+          </a:fillRef>
+          <a:effectRef idx="2">
+            <a:schemeClr val="accent1"/>
+          </a:effectRef>
+          <a:fontRef idx="minor">
+            <a:schemeClr val="lt1"/>
+          </a:fontRef>
+        </p:style>
+        <p:txBody>
+          <a:bodyPr rtlCol="0" anchor="ctr" wrap="square"/>
+          <a:lstStyle/>
+          <a:p>
+            <a:pPr algn="ctr">
+              <a:defRPr sz="1500" b="1">
+                <a:solidFill>
+                  <a:srgbClr val="6366F1"/>
+                </a:solidFill>
+              </a:defRPr>
+            </a:pPr>
+            <a:r>
+              <a:t>DOCKER / IaC</a:t>
+            </a:r>
+          </a:p>
+          <a:p>
             <a:br/>
-            <a:r>
-              <a:t>• Explicaciones didácticas en cada MR.</a:t>
-            </a:r>
+            <a:pPr>
+              <a:defRPr sz="1200">
+                <a:solidFill>
+                  <a:srgbClr val="F8FAFC"/>
+                </a:solidFill>
+              </a:defRPr>
+            </a:pPr>
+            <a:r>
+              <a:t>Hardening de infraestructura (ej: DOCKER-MISSING-NON-ROOT-USER, buckets S3 públicos).</a:t>
+            </a:r>
+          </a:p>
+        </p:txBody>
+      </p:sp>
+      <p:sp>
+        <p:nvSpPr>
+          <p:cNvPr id="8" name="Rounded Rectangle 7"/>
+          <p:cNvSpPr/>
+          <p:nvPr/>
+        </p:nvSpPr>
+        <p:spPr>
+          <a:xfrm>
+            <a:off x="4297680" y="3931920"/>
+            <a:ext cx="3383280" cy="2011680"/>
+          </a:xfrm>
+          <a:prstGeom prst="roundRect">
+            <a:avLst/>
+          </a:prstGeom>
+          <a:solidFill>
+            <a:srgbClr val="1E293B"/>
+          </a:solidFill>
+          <a:ln>
+            <a:solidFill>
+              <a:srgbClr val="334155"/>
+            </a:solidFill>
+          </a:ln>
+        </p:spPr>
+        <p:style>
+          <a:lnRef idx="1">
+            <a:schemeClr val="accent1"/>
+          </a:lnRef>
+          <a:fillRef idx="3">
+            <a:schemeClr val="accent1"/>
+          </a:fillRef>
+          <a:effectRef idx="2">
+            <a:schemeClr val="accent1"/>
+          </a:effectRef>
+          <a:fontRef idx="minor">
+            <a:schemeClr val="lt1"/>
+          </a:fontRef>
+        </p:style>
+        <p:txBody>
+          <a:bodyPr rtlCol="0" anchor="ctr" wrap="square"/>
+          <a:lstStyle/>
+          <a:p>
+            <a:pPr algn="ctr">
+              <a:defRPr sz="1500" b="1">
+                <a:solidFill>
+                  <a:srgbClr val="6366F1"/>
+                </a:solidFill>
+              </a:defRPr>
+            </a:pPr>
+            <a:r>
+              <a:t>STD-STRIDE / ISO25010</a:t>
+            </a:r>
+          </a:p>
+          <a:p>
             <a:br/>
-            <a:r>
-              <a:t>• Detección temprana en el ciclo DevSecOps.</a:t>
+            <a:pPr>
+              <a:defRPr sz="1200">
+                <a:solidFill>
+                  <a:srgbClr val="F8FAFC"/>
+                </a:solidFill>
+              </a:defRPr>
+            </a:pPr>
+            <a:r>
+              <a:t>Violaciones arquitectónicas y calidad de software (ej: STD-STRIDE-JWT-INSECURE-ALG).</a:t>
+            </a:r>
+          </a:p>
+        </p:txBody>
+      </p:sp>
+      <p:sp>
+        <p:nvSpPr>
+          <p:cNvPr id="9" name="Rounded Rectangle 8"/>
+          <p:cNvSpPr/>
+          <p:nvPr/>
+        </p:nvSpPr>
+        <p:spPr>
+          <a:xfrm>
+            <a:off x="7863840" y="3931920"/>
+            <a:ext cx="3383280" cy="2011680"/>
+          </a:xfrm>
+          <a:prstGeom prst="roundRect">
+            <a:avLst/>
+          </a:prstGeom>
+          <a:solidFill>
+            <a:srgbClr val="1E293B"/>
+          </a:solidFill>
+          <a:ln>
+            <a:solidFill>
+              <a:srgbClr val="334155"/>
+            </a:solidFill>
+          </a:ln>
+        </p:spPr>
+        <p:style>
+          <a:lnRef idx="1">
+            <a:schemeClr val="accent1"/>
+          </a:lnRef>
+          <a:fillRef idx="3">
+            <a:schemeClr val="accent1"/>
+          </a:fillRef>
+          <a:effectRef idx="2">
+            <a:schemeClr val="accent1"/>
+          </a:effectRef>
+          <a:fontRef idx="minor">
+            <a:schemeClr val="lt1"/>
+          </a:fontRef>
+        </p:style>
+        <p:txBody>
+          <a:bodyPr rtlCol="0" anchor="ctr" wrap="square"/>
+          <a:lstStyle/>
+          <a:p>
+            <a:pPr algn="ctr">
+              <a:defRPr sz="1500" b="1">
+                <a:solidFill>
+                  <a:srgbClr val="6366F1"/>
+                </a:solidFill>
+              </a:defRPr>
+            </a:pPr>
+            <a:r>
+              <a:t>CTI-IOC / ITDR / eBPF</a:t>
+            </a:r>
+          </a:p>
+          <a:p>
+            <a:br/>
+            <a:pPr>
+              <a:defRPr sz="1200">
+                <a:solidFill>
+                  <a:srgbClr val="F8FAFC"/>
+                </a:solidFill>
+              </a:defRPr>
+            </a:pPr>
+            <a:r>
+              <a:t>Vectores runtime (Password Spraying en Authentik, C2 IPs activas de Feodo Tracker, syscalls Linux).</a:t>
             </a:r>
           </a:p>
         </p:txBody>

</xml_diff>

<commit_message>
docs(pptx): Incorporate Board Executive Summary and 100% International Standard Implementation Plan slides (16 slides total)
</commit_message>
<xml_diff>
--- a/Presentacion_Centinela_AI.pptx
+++ b/Presentacion_Centinela_AI.pptx
@@ -19,6 +19,8 @@
     <p:sldId id="267" r:id="rId18"/>
     <p:sldId id="268" r:id="rId19"/>
     <p:sldId id="269" r:id="rId20"/>
+    <p:sldId id="270" r:id="rId21"/>
+    <p:sldId id="271" r:id="rId22"/>
   </p:sldIdLst>
   <p:sldSz cx="12191695" cy="6858000" type="screen4x3"/>
   <p:notesSz cx="6858000" cy="9144000"/>
@@ -4639,8 +4641,8 @@
         </p:nvSpPr>
         <p:spPr>
           <a:xfrm>
-            <a:off x="1371600" y="1097280"/>
-            <a:ext cx="9448495" cy="4572000"/>
+            <a:off x="914400" y="1097280"/>
+            <a:ext cx="10362895" cy="4572000"/>
           </a:xfrm>
           <a:prstGeom prst="roundRect">
             <a:avLst/>
@@ -4673,6 +4675,475 @@
           <a:lstStyle/>
           <a:p>
             <a:pPr algn="ctr">
+              <a:defRPr sz="2600" b="1">
+                <a:solidFill>
+                  <a:srgbClr val="0EA5E9"/>
+                </a:solidFill>
+              </a:defRPr>
+            </a:pPr>
+            <a:r>
+              <a:t>📝 RESUMEN PARA LA JUNTA DIRECTIVA</a:t>
+            </a:r>
+          </a:p>
+          <a:p>
+            <a:br/>
+            <a:pPr algn="ctr">
+              <a:defRPr sz="1600" b="1">
+                <a:solidFill>
+                  <a:srgbClr val="F8FAFC"/>
+                </a:solidFill>
+              </a:defRPr>
+            </a:pPr>
+            <a:r>
+              <a:t>"Centinela AI ya cumple con más del 90% de las exigencias funcionales de un XDR de clase mundial, con la ventaja competitiva de ser una herramienta soberana (sin fuga de datos a la nube de terceros) y de unir en una sola consola lo que a las grandes empresas les toma comprar entre 3 y 4 soluciones distintas (EDR + DevSecOps + Auditoría CMMI/ISO)."</a:t>
+            </a:r>
+          </a:p>
+          <a:p>
+            <a:br/>
+            <a:pPr algn="ctr">
+              <a:defRPr sz="1500" b="1">
+                <a:solidFill>
+                  <a:srgbClr val="22C55E"/>
+                </a:solidFill>
+              </a:defRPr>
+            </a:pPr>
+            <a:r>
+              <a:t>⭐ Con la ejecución del Plan de Implementación de 3 Fases (CSPM Cloud, K8s Admission Controller y Certificación de Producto), Centinela AI alcanzará el 100% de cobertura y certificación internacional de producto.</a:t>
+            </a:r>
+          </a:p>
+        </p:txBody>
+      </p:sp>
+    </p:spTree>
+  </p:cSld>
+  <p:clrMapOvr>
+    <a:masterClrMapping/>
+  </p:clrMapOvr>
+</p:sld>
+</file>
+
+<file path=ppt/slides/slide15.xml><?xml version="1.0" encoding="utf-8"?>
+<p:sld xmlns:a="http://schemas.openxmlformats.org/drawingml/2006/main" xmlns:p="http://schemas.openxmlformats.org/presentationml/2006/main" xmlns:r="http://schemas.openxmlformats.org/officeDocument/2006/relationships">
+  <p:cSld>
+    <p:spTree>
+      <p:nvGrpSpPr>
+        <p:cNvPr id="1" name=""/>
+        <p:cNvGrpSpPr/>
+        <p:nvPr/>
+      </p:nvGrpSpPr>
+      <p:grpSpPr/>
+      <p:sp>
+        <p:nvSpPr>
+          <p:cNvPr id="2" name="Rectangle 1"/>
+          <p:cNvSpPr/>
+          <p:nvPr/>
+        </p:nvSpPr>
+        <p:spPr>
+          <a:xfrm>
+            <a:off x="0" y="0"/>
+            <a:ext cx="12191695" cy="6858000"/>
+          </a:xfrm>
+          <a:prstGeom prst="rect">
+            <a:avLst/>
+          </a:prstGeom>
+          <a:solidFill>
+            <a:srgbClr val="0F172A"/>
+          </a:solidFill>
+          <a:ln>
+            <a:solidFill>
+              <a:srgbClr val="0F172A"/>
+            </a:solidFill>
+          </a:ln>
+        </p:spPr>
+        <p:style>
+          <a:lnRef idx="1">
+            <a:schemeClr val="accent1"/>
+          </a:lnRef>
+          <a:fillRef idx="3">
+            <a:schemeClr val="accent1"/>
+          </a:fillRef>
+          <a:effectRef idx="2">
+            <a:schemeClr val="accent1"/>
+          </a:effectRef>
+          <a:fontRef idx="minor">
+            <a:schemeClr val="lt1"/>
+          </a:fontRef>
+        </p:style>
+        <p:txBody>
+          <a:bodyPr rtlCol="0" anchor="ctr"/>
+          <a:lstStyle/>
+          <a:p>
+            <a:pPr algn="ctr"/>
+          </a:p>
+        </p:txBody>
+      </p:sp>
+      <p:sp>
+        <p:nvSpPr>
+          <p:cNvPr id="3" name="TextBox 2"/>
+          <p:cNvSpPr txBox="1"/>
+          <p:nvPr/>
+        </p:nvSpPr>
+        <p:spPr>
+          <a:xfrm>
+            <a:off x="731520" y="365760"/>
+            <a:ext cx="10698480" cy="822960"/>
+          </a:xfrm>
+          <a:prstGeom prst="rect">
+            <a:avLst/>
+          </a:prstGeom>
+          <a:noFill/>
+        </p:spPr>
+        <p:txBody>
+          <a:bodyPr wrap="square">
+            <a:spAutoFit/>
+          </a:bodyPr>
+          <a:lstStyle/>
+          <a:p>
+            <a:pPr>
+              <a:defRPr sz="2600" b="1">
+                <a:solidFill>
+                  <a:srgbClr val="0EA5E9"/>
+                </a:solidFill>
+              </a:defRPr>
+            </a:pPr>
+            <a:r>
+              <a:t>10. Plan de Implementación para el 100% Estándar Internacional</a:t>
+            </a:r>
+          </a:p>
+          <a:p>
+            <a:pPr>
+              <a:defRPr sz="1300">
+                <a:solidFill>
+                  <a:srgbClr val="94A3B8"/>
+                </a:solidFill>
+              </a:defRPr>
+            </a:pPr>
+            <a:r>
+              <a:t>Hoja de ruta estratégica para la cobertura total y certificación internacional</a:t>
+            </a:r>
+          </a:p>
+        </p:txBody>
+      </p:sp>
+      <p:sp>
+        <p:nvSpPr>
+          <p:cNvPr id="4" name="Rounded Rectangle 3"/>
+          <p:cNvSpPr/>
+          <p:nvPr/>
+        </p:nvSpPr>
+        <p:spPr>
+          <a:xfrm>
+            <a:off x="731520" y="1645920"/>
+            <a:ext cx="3383280" cy="4389120"/>
+          </a:xfrm>
+          <a:prstGeom prst="roundRect">
+            <a:avLst/>
+          </a:prstGeom>
+          <a:solidFill>
+            <a:srgbClr val="1E293B"/>
+          </a:solidFill>
+          <a:ln>
+            <a:solidFill>
+              <a:srgbClr val="334155"/>
+            </a:solidFill>
+          </a:ln>
+        </p:spPr>
+        <p:style>
+          <a:lnRef idx="1">
+            <a:schemeClr val="accent1"/>
+          </a:lnRef>
+          <a:fillRef idx="3">
+            <a:schemeClr val="accent1"/>
+          </a:fillRef>
+          <a:effectRef idx="2">
+            <a:schemeClr val="accent1"/>
+          </a:effectRef>
+          <a:fontRef idx="minor">
+            <a:schemeClr val="lt1"/>
+          </a:fontRef>
+        </p:style>
+        <p:txBody>
+          <a:bodyPr rtlCol="0" anchor="ctr" wrap="square"/>
+          <a:lstStyle/>
+          <a:p>
+            <a:pPr algn="ctr">
+              <a:defRPr sz="1600" b="1">
+                <a:solidFill>
+                  <a:srgbClr val="0EA5E9"/>
+                </a:solidFill>
+              </a:defRPr>
+            </a:pPr>
+            <a:r>
+              <a:t>Fase I: CSPM Cloud-Native (AWS / GCP / Azure)</a:t>
+            </a:r>
+          </a:p>
+          <a:p>
+            <a:br/>
+            <a:pPr>
+              <a:defRPr sz="1300">
+                <a:solidFill>
+                  <a:srgbClr val="F8FAFC"/>
+                </a:solidFill>
+              </a:defRPr>
+            </a:pPr>
+            <a:r>
+              <a:t>Integración de conectores API para auditoría en caliente de buckets S3, políticas IAM de menor privilegio y Security Groups mediante Prowler.</a:t>
+            </a:r>
+            <a:br/>
+            <a:br/>
+            <a:r>
+              <a:t>➡ Completa el módulo de Cloud Security Posture Management (CSPM).</a:t>
+            </a:r>
+          </a:p>
+        </p:txBody>
+      </p:sp>
+      <p:sp>
+        <p:nvSpPr>
+          <p:cNvPr id="5" name="Rounded Rectangle 4"/>
+          <p:cNvSpPr/>
+          <p:nvPr/>
+        </p:nvSpPr>
+        <p:spPr>
+          <a:xfrm>
+            <a:off x="4297680" y="1645920"/>
+            <a:ext cx="3383280" cy="4389120"/>
+          </a:xfrm>
+          <a:prstGeom prst="roundRect">
+            <a:avLst/>
+          </a:prstGeom>
+          <a:solidFill>
+            <a:srgbClr val="1E293B"/>
+          </a:solidFill>
+          <a:ln>
+            <a:solidFill>
+              <a:srgbClr val="334155"/>
+            </a:solidFill>
+          </a:ln>
+        </p:spPr>
+        <p:style>
+          <a:lnRef idx="1">
+            <a:schemeClr val="accent1"/>
+          </a:lnRef>
+          <a:fillRef idx="3">
+            <a:schemeClr val="accent1"/>
+          </a:fillRef>
+          <a:effectRef idx="2">
+            <a:schemeClr val="accent1"/>
+          </a:effectRef>
+          <a:fontRef idx="minor">
+            <a:schemeClr val="lt1"/>
+          </a:fontRef>
+        </p:style>
+        <p:txBody>
+          <a:bodyPr rtlCol="0" anchor="ctr" wrap="square"/>
+          <a:lstStyle/>
+          <a:p>
+            <a:pPr algn="ctr">
+              <a:defRPr sz="1600" b="1">
+                <a:solidFill>
+                  <a:srgbClr val="6366F1"/>
+                </a:solidFill>
+              </a:defRPr>
+            </a:pPr>
+            <a:r>
+              <a:t>Fase II: Admission Controller eBPF para Kubernetes</a:t>
+            </a:r>
+          </a:p>
+          <a:p>
+            <a:br/>
+            <a:pPr>
+              <a:defRPr sz="1300">
+                <a:solidFill>
+                  <a:srgbClr val="F8FAFC"/>
+                </a:solidFill>
+              </a:defRPr>
+            </a:pPr>
+            <a:r>
+              <a:t>Despliegue de controlador de admisión (Helm Chart) para firma de imágenes y verificación de SBOM antes del paso a producción.</a:t>
+            </a:r>
+            <a:br/>
+            <a:br/>
+            <a:r>
+              <a:t>➡ Garantiza la Seguridad Runtime 100% en Contenedores &amp; Microservicios.</a:t>
+            </a:r>
+          </a:p>
+        </p:txBody>
+      </p:sp>
+      <p:sp>
+        <p:nvSpPr>
+          <p:cNvPr id="6" name="Rounded Rectangle 5"/>
+          <p:cNvSpPr/>
+          <p:nvPr/>
+        </p:nvSpPr>
+        <p:spPr>
+          <a:xfrm>
+            <a:off x="7863840" y="1645920"/>
+            <a:ext cx="3383280" cy="4389120"/>
+          </a:xfrm>
+          <a:prstGeom prst="roundRect">
+            <a:avLst/>
+          </a:prstGeom>
+          <a:solidFill>
+            <a:srgbClr val="1E293B"/>
+          </a:solidFill>
+          <a:ln>
+            <a:solidFill>
+              <a:srgbClr val="334155"/>
+            </a:solidFill>
+          </a:ln>
+        </p:spPr>
+        <p:style>
+          <a:lnRef idx="1">
+            <a:schemeClr val="accent1"/>
+          </a:lnRef>
+          <a:fillRef idx="3">
+            <a:schemeClr val="accent1"/>
+          </a:fillRef>
+          <a:effectRef idx="2">
+            <a:schemeClr val="accent1"/>
+          </a:effectRef>
+          <a:fontRef idx="minor">
+            <a:schemeClr val="lt1"/>
+          </a:fontRef>
+        </p:style>
+        <p:txBody>
+          <a:bodyPr rtlCol="0" anchor="ctr" wrap="square"/>
+          <a:lstStyle/>
+          <a:p>
+            <a:pPr algn="ctr">
+              <a:defRPr sz="1600" b="1">
+                <a:solidFill>
+                  <a:srgbClr val="22C55E"/>
+                </a:solidFill>
+              </a:defRPr>
+            </a:pPr>
+            <a:r>
+              <a:t>Fase III: Auditoría Externa y Certificación de Producto</a:t>
+            </a:r>
+          </a:p>
+          <a:p>
+            <a:br/>
+            <a:pPr>
+              <a:defRPr sz="1300">
+                <a:solidFill>
+                  <a:srgbClr val="F8FAFC"/>
+                </a:solidFill>
+              </a:defRPr>
+            </a:pPr>
+            <a:r>
+              <a:t>Proceso de auditoría formal por firma acreditada para certificaciones SOC 2 Type II e ISO/IEC 27001/25001.</a:t>
+            </a:r>
+            <a:br/>
+            <a:br/>
+            <a:r>
+              <a:t>➡ Otorga la Certificación Oficial de Producto Enterprise comercializable mundialmente.</a:t>
+            </a:r>
+          </a:p>
+        </p:txBody>
+      </p:sp>
+    </p:spTree>
+  </p:cSld>
+  <p:clrMapOvr>
+    <a:masterClrMapping/>
+  </p:clrMapOvr>
+</p:sld>
+</file>
+
+<file path=ppt/slides/slide16.xml><?xml version="1.0" encoding="utf-8"?>
+<p:sld xmlns:a="http://schemas.openxmlformats.org/drawingml/2006/main" xmlns:p="http://schemas.openxmlformats.org/presentationml/2006/main" xmlns:r="http://schemas.openxmlformats.org/officeDocument/2006/relationships">
+  <p:cSld>
+    <p:spTree>
+      <p:nvGrpSpPr>
+        <p:cNvPr id="1" name=""/>
+        <p:cNvGrpSpPr/>
+        <p:nvPr/>
+      </p:nvGrpSpPr>
+      <p:grpSpPr/>
+      <p:sp>
+        <p:nvSpPr>
+          <p:cNvPr id="2" name="Rectangle 1"/>
+          <p:cNvSpPr/>
+          <p:nvPr/>
+        </p:nvSpPr>
+        <p:spPr>
+          <a:xfrm>
+            <a:off x="0" y="0"/>
+            <a:ext cx="12191695" cy="6858000"/>
+          </a:xfrm>
+          <a:prstGeom prst="rect">
+            <a:avLst/>
+          </a:prstGeom>
+          <a:solidFill>
+            <a:srgbClr val="0F172A"/>
+          </a:solidFill>
+          <a:ln>
+            <a:solidFill>
+              <a:srgbClr val="0F172A"/>
+            </a:solidFill>
+          </a:ln>
+        </p:spPr>
+        <p:style>
+          <a:lnRef idx="1">
+            <a:schemeClr val="accent1"/>
+          </a:lnRef>
+          <a:fillRef idx="3">
+            <a:schemeClr val="accent1"/>
+          </a:fillRef>
+          <a:effectRef idx="2">
+            <a:schemeClr val="accent1"/>
+          </a:effectRef>
+          <a:fontRef idx="minor">
+            <a:schemeClr val="lt1"/>
+          </a:fontRef>
+        </p:style>
+        <p:txBody>
+          <a:bodyPr rtlCol="0" anchor="ctr"/>
+          <a:lstStyle/>
+          <a:p>
+            <a:pPr algn="ctr"/>
+          </a:p>
+        </p:txBody>
+      </p:sp>
+      <p:sp>
+        <p:nvSpPr>
+          <p:cNvPr id="3" name="Rounded Rectangle 2"/>
+          <p:cNvSpPr/>
+          <p:nvPr/>
+        </p:nvSpPr>
+        <p:spPr>
+          <a:xfrm>
+            <a:off x="1371600" y="1097280"/>
+            <a:ext cx="9448495" cy="4572000"/>
+          </a:xfrm>
+          <a:prstGeom prst="roundRect">
+            <a:avLst/>
+          </a:prstGeom>
+          <a:solidFill>
+            <a:srgbClr val="1E293B"/>
+          </a:solidFill>
+          <a:ln w="25400">
+            <a:solidFill>
+              <a:srgbClr val="0EA5E9"/>
+            </a:solidFill>
+          </a:ln>
+        </p:spPr>
+        <p:style>
+          <a:lnRef idx="1">
+            <a:schemeClr val="accent1"/>
+          </a:lnRef>
+          <a:fillRef idx="3">
+            <a:schemeClr val="accent1"/>
+          </a:fillRef>
+          <a:effectRef idx="2">
+            <a:schemeClr val="accent1"/>
+          </a:effectRef>
+          <a:fontRef idx="minor">
+            <a:schemeClr val="lt1"/>
+          </a:fontRef>
+        </p:style>
+        <p:txBody>
+          <a:bodyPr rtlCol="0" anchor="ctr" wrap="square"/>
+          <a:lstStyle/>
+          <a:p>
+            <a:pPr algn="ctr">
               <a:defRPr sz="2800" b="1">
                 <a:solidFill>
                   <a:srgbClr val="0EA5E9"/>
@@ -4706,7 +5177,7 @@
               </a:defRPr>
             </a:pPr>
             <a:r>
-              <a:t>Solicitamos la aprobación de los Directivos para avanzar en la Fase 2 del desarrollo:</a:t>
+              <a:t>Solicitamos la aprobación de los Directivos para avanzar en la ejecución del Plan de Implementación al 100%:</a:t>
             </a:r>
           </a:p>
           <a:p>
@@ -4718,15 +5189,15 @@
               </a:defRPr>
             </a:pPr>
             <a:r>
-              <a:t>1. Conectores nativos multi-nube (AWS, GCP, Azure)</a:t>
+              <a:t>1. Conectores nativos multi-nube (AWS, GCP, Azure - CSPM)</a:t>
             </a:r>
             <a:br/>
             <a:r>
-              <a:t>2. Arquitectura Multi-Tenancy para comercialización SaaS</a:t>
+              <a:t>2. Admission Controller eBPF para Kubernetes en caliente</a:t>
             </a:r>
             <a:br/>
             <a:r>
-              <a:t>3. Proceso de certificación SOC 2 Type II e ISO 27001</a:t>
+              <a:t>3. Proceso de certificación oficial SOC 2 Type II e ISO 27001/25001</a:t>
             </a:r>
           </a:p>
         </p:txBody>

</xml_diff>